<commit_message>
Propagate engineering depth: Arabic chapter, dashboard sections, slides & guide
- Arabic mirror engineering-background-ar.md (+pdf 13pp/docx), wired into `make docs-ar`.
- Dashboard (app.py): two new sections — "Motor & Control System" (construction,
  operating principle, FOC, PMSM-vs-relatives, tabbed, with figures) and "Fault
  Detection Methods" (manual vs automated taxonomy, MCSA, why CWT+CNN improves).
- Slides EN+AR: added Motor&control, PMSM-vs-relatives, and detection-landscape
  slides with figures; rebuilt pptx+pdf.
- Study guide EN+AR: new "Machine & control questions" Q&A (M1-M7); rebuilt pdf.
- All bilingual PDFs rebuilt, 0 missing glyphs.

Co-Authored-By: Claude Opus 4.8 (1M context) <noreply@anthropic.com>
</commit_message>
<xml_diff>
--- a/docs/build/slides-ar.pptx
+++ b/docs/build/slides-ar.pptx
@@ -26,6 +26,9 @@
     <p:sldId id="274" r:id="rId20"/>
     <p:sldId id="275" r:id="rId21"/>
     <p:sldId id="276" r:id="rId22"/>
+    <p:sldId id="277" r:id="rId23"/>
+    <p:sldId id="278" r:id="rId24"/>
+    <p:sldId id="279" r:id="rId25"/>
   </p:sldIdLst>
   <p:sldSz cx="9144000" cy="5143500" type="screen16x9"/>
   <p:notesSz cx="6858000" cy="9144000"/>
@@ -3164,6 +3167,373 @@
       </p:grpSpPr>
       <p:sp>
         <p:nvSpPr>
+          <p:cNvPr id="3" name="Content Placeholder 2"/>
+          <p:cNvSpPr>
+            <a:spLocks noGrp="1"/>
+          </p:cNvSpPr>
+          <p:nvPr>
+            <p:ph idx="1"/>
+          </p:nvPr>
+        </p:nvSpPr>
+        <p:spPr/>
+        <p:txBody>
+          <a:bodyPr/>
+          <a:lstStyle/>
+          <a:p>
+            <a:pPr lvl="0" indent="0" marL="0">
+              <a:spcBef>
+                <a:spcPts val="3000"/>
+              </a:spcBef>
+              <a:buNone/>
+            </a:pPr>
+            <a:r>
+              <a:rPr b="1"/>
+              <a:t>٥. لماذا المويجات وليس فورييه؟</a:t>
+            </a:r>
+          </a:p>
+          <a:p>
+            <a:pPr lvl="0"/>
+            <a:r>
+              <a:rPr/>
+              <a:t>تحويل فورييه </a:t>
+            </a:r>
+            <a:r>
+              <a:rPr b="1"/>
+              <a:t>أعمى زمنياً</a:t>
+            </a:r>
+            <a:r>
+              <a:rPr/>
+              <a:t> — لا يخبرنا </a:t>
+            </a:r>
+            <a:r>
+              <a:rPr i="1"/>
+              <a:t>متى</a:t>
+            </a:r>
+            <a:r>
+              <a:rPr/>
+              <a:t> يحدث التردد.</a:t>
+            </a:r>
+          </a:p>
+          <a:p>
+            <a:pPr lvl="0"/>
+            <a:r>
+              <a:rPr/>
+              <a:t>إشارات الأعطال </a:t>
+            </a:r>
+            <a:r>
+              <a:rPr b="1"/>
+              <a:t>غير مستقرة</a:t>
+            </a:r>
+            <a:r>
+              <a:rPr/>
+              <a:t> (عابرة، تعتمد على الحمل).</a:t>
+            </a:r>
+          </a:p>
+          <a:p>
+            <a:pPr lvl="0"/>
+            <a:r>
+              <a:rPr/>
+              <a:t>مبدأ عدم اليقين: </a:t>
+            </a:r>
+            <a:r>
+              <a:rPr>
+                <a:latin typeface="Courier"/>
+              </a:rPr>
+              <a:t>Δt · Δf ≥ ثابت</a:t>
+            </a:r>
+            <a:r>
+              <a:rPr/>
+              <a:t> — يستحيل دقّة زمنية وترددية مثاليّتان معاً.</a:t>
+            </a:r>
+          </a:p>
+          <a:p>
+            <a:pPr lvl="0"/>
+            <a:r>
+              <a:rPr b="1"/>
+              <a:t>المويجات</a:t>
+            </a:r>
+            <a:r>
+              <a:rPr/>
+              <a:t> = موجات قصيرة موضعية ⟵ دقّة ترددية متغيّرة، مثاليّة للظواهر العابرة.</a:t>
+            </a:r>
+          </a:p>
+        </p:txBody>
+      </p:sp>
+    </p:spTree>
+  </p:cSld>
+</p:sld>
+</file>
+
+<file path=ppt/slides/slide11.xml><?xml version="1.0" encoding="utf-8"?>
+<p:sld xmlns:a="http://schemas.openxmlformats.org/drawingml/2006/main" xmlns:r="http://schemas.openxmlformats.org/officeDocument/2006/relationships" xmlns:p="http://schemas.openxmlformats.org/presentationml/2006/main">
+  <p:cSld>
+    <p:spTree>
+      <p:nvGrpSpPr>
+        <p:cNvPr id="1" name=""/>
+        <p:cNvGrpSpPr/>
+        <p:nvPr/>
+      </p:nvGrpSpPr>
+      <p:grpSpPr>
+        <a:xfrm>
+          <a:off x="0" y="0"/>
+          <a:ext cx="0" cy="0"/>
+          <a:chOff x="0" y="0"/>
+          <a:chExt cx="0" cy="0"/>
+        </a:xfrm>
+      </p:grpSpPr>
+      <p:sp>
+        <p:nvSpPr>
+          <p:cNvPr id="3" name="Content Placeholder 2"/>
+          <p:cNvSpPr>
+            <a:spLocks noGrp="1"/>
+          </p:cNvSpPr>
+          <p:nvPr>
+            <p:ph idx="1"/>
+          </p:nvPr>
+        </p:nvSpPr>
+        <p:spPr/>
+        <p:txBody>
+          <a:bodyPr/>
+          <a:lstStyle/>
+          <a:p>
+            <a:pPr lvl="0" indent="0" marL="0">
+              <a:spcBef>
+                <a:spcPts val="3000"/>
+              </a:spcBef>
+              <a:buNone/>
+            </a:pPr>
+            <a:r>
+              <a:rPr b="1"/>
+              <a:t>٦. تحويل المويجات المستمر (CWT) ومخطط الطيف</a:t>
+            </a:r>
+          </a:p>
+          <a:p>
+            <a:pPr lvl="0"/>
+            <a:r>
+              <a:rPr/>
+              <a:t>نُقيّس مويجة </a:t>
+            </a:r>
+            <a:r>
+              <a:rPr b="1"/>
+              <a:t>Morlet</a:t>
+            </a:r>
+            <a:r>
+              <a:rPr/>
+              <a:t> (مقبض التردد) ونُزلقها (مقبض الزمن).</a:t>
+            </a:r>
+          </a:p>
+          <a:p>
+            <a:pPr lvl="0"/>
+            <a:r>
+              <a:rPr/>
+              <a:t>كلّ معامل = </a:t>
+            </a:r>
+            <a:r>
+              <a:rPr b="1"/>
+              <a:t>تشابه</a:t>
+            </a:r>
+            <a:r>
+              <a:rPr/>
+              <a:t> الإشارة مع تلك الموجة عند ذلك الزمن.</a:t>
+            </a:r>
+          </a:p>
+          <a:p>
+            <a:pPr lvl="0"/>
+            <a:r>
+              <a:rPr b="1"/>
+              <a:t>Scalogram</a:t>
+            </a:r>
+            <a:r>
+              <a:rPr/>
+              <a:t> = صورة ملوّنة للطاقة مقابل الزمن (س) والتردد (ص).</a:t>
+            </a:r>
+          </a:p>
+          <a:p>
+            <a:pPr lvl="0"/>
+            <a:r>
+              <a:rPr/>
+              <a:t>الحُزَم والنطاقات الجانبية الساطعة = بصمات العطل التي </a:t>
+            </a:r>
+            <a:r>
+              <a:rPr i="1"/>
+              <a:t>تراها</a:t>
+            </a:r>
+            <a:r>
+              <a:rPr/>
+              <a:t> الشبكة.</a:t>
+            </a:r>
+          </a:p>
+        </p:txBody>
+      </p:sp>
+    </p:spTree>
+  </p:cSld>
+</p:sld>
+</file>
+
+<file path=ppt/slides/slide12.xml><?xml version="1.0" encoding="utf-8"?>
+<p:sld xmlns:a="http://schemas.openxmlformats.org/drawingml/2006/main" xmlns:r="http://schemas.openxmlformats.org/officeDocument/2006/relationships" xmlns:p="http://schemas.openxmlformats.org/presentationml/2006/main">
+  <p:cSld>
+    <p:spTree>
+      <p:nvGrpSpPr>
+        <p:cNvPr id="1" name=""/>
+        <p:cNvGrpSpPr/>
+        <p:nvPr/>
+      </p:nvGrpSpPr>
+      <p:grpSpPr>
+        <a:xfrm>
+          <a:off x="0" y="0"/>
+          <a:ext cx="0" cy="0"/>
+          <a:chOff x="0" y="0"/>
+          <a:chExt cx="0" cy="0"/>
+        </a:xfrm>
+      </p:grpSpPr>
+      <p:sp>
+        <p:nvSpPr>
+          <p:cNvPr id="4" name="Text Placeholder 3"/>
+          <p:cNvSpPr>
+            <a:spLocks noGrp="1"/>
+          </p:cNvSpPr>
+          <p:nvPr>
+            <p:ph idx="2" sz="half" type="body"/>
+          </p:nvPr>
+        </p:nvSpPr>
+        <p:spPr/>
+        <p:txBody>
+          <a:bodyPr/>
+          <a:lstStyle/>
+          <a:p>
+            <a:pPr lvl="0" indent="0" marL="0">
+              <a:spcBef>
+                <a:spcPts val="3000"/>
+              </a:spcBef>
+              <a:buNone/>
+            </a:pPr>
+            <a:r>
+              <a:rPr b="1"/>
+              <a:t>٧. أمثلة على المخططات (بيانات KAIST الحقيقية)</a:t>
+            </a:r>
+          </a:p>
+        </p:txBody>
+      </p:sp>
+      <p:pic>
+        <p:nvPicPr>
+          <p:cNvPr descr="../../results/example_scalograms_real.png" id="0" name="Picture 1"/>
+          <p:cNvPicPr>
+            <a:picLocks noGrp="1" noChangeAspect="1"/>
+          </p:cNvPicPr>
+          <p:nvPr/>
+        </p:nvPicPr>
+        <p:blipFill>
+          <a:blip r:embed="rId2"/>
+          <a:stretch>
+            <a:fillRect/>
+          </a:stretch>
+        </p:blipFill>
+        <p:spPr bwMode="auto">
+          <a:xfrm>
+            <a:off x="3568700" y="1473200"/>
+            <a:ext cx="5105400" cy="1346200"/>
+          </a:xfrm>
+          <a:prstGeom prst="rect">
+            <a:avLst/>
+          </a:prstGeom>
+          <a:noFill/>
+          <a:ln w="9525">
+            <a:noFill/>
+            <a:headEnd/>
+            <a:tailEnd/>
+          </a:ln>
+        </p:spPr>
+      </p:pic>
+      <p:sp>
+        <p:nvSpPr>
+          <p:cNvPr id="1" name="TextBox 3"/>
+          <p:cNvSpPr txBox="1"/>
+          <p:nvPr>
+            <p:ph idx="1"/>
+          </p:nvPr>
+        </p:nvSpPr>
+        <p:spPr>
+          <a:xfrm>
+            <a:off x="3568700" y="4076700"/>
+            <a:ext cx="5105400" cy="508000"/>
+          </a:xfrm>
+          <a:prstGeom prst="rect">
+            <a:avLst/>
+          </a:prstGeom>
+          <a:noFill/>
+        </p:spPr>
+        <p:txBody>
+          <a:bodyPr/>
+          <a:lstStyle/>
+          <a:p>
+            <a:pPr lvl="0" indent="0" marL="0" algn="ctr">
+              <a:buNone/>
+            </a:pPr>
+            <a:r>
+              <a:rPr/>
+              <a:t>w:1000</a:t>
+            </a:r>
+          </a:p>
+        </p:txBody>
+      </p:sp>
+      <p:sp>
+        <p:nvSpPr>
+          <p:cNvPr id="3" name="Content Placeholder 2"/>
+          <p:cNvSpPr>
+            <a:spLocks noGrp="1"/>
+          </p:cNvSpPr>
+          <p:nvPr>
+            <p:ph idx="1"/>
+          </p:nvPr>
+        </p:nvSpPr>
+        <p:spPr/>
+        <p:txBody>
+          <a:bodyPr/>
+          <a:lstStyle/>
+          <a:p>
+            <a:pPr lvl="0" indent="0" marL="0">
+              <a:buNone/>
+            </a:pPr>
+            <a:r>
+              <a:rPr/>
+              <a:t>العطل بين اللفات يُثري محتوى الزمن–التردد في قناة </a:t>
+            </a:r>
+            <a:r>
+              <a:rPr b="1"/>
+              <a:t>الاهتزاز</a:t>
+            </a:r>
+            <a:r>
+              <a:rPr/>
+              <a:t> بوضوح.</a:t>
+            </a:r>
+          </a:p>
+        </p:txBody>
+      </p:sp>
+    </p:spTree>
+  </p:cSld>
+</p:sld>
+</file>
+
+<file path=ppt/slides/slide13.xml><?xml version="1.0" encoding="utf-8"?>
+<p:sld xmlns:a="http://schemas.openxmlformats.org/drawingml/2006/main" xmlns:r="http://schemas.openxmlformats.org/officeDocument/2006/relationships" xmlns:p="http://schemas.openxmlformats.org/presentationml/2006/main">
+  <p:cSld>
+    <p:spTree>
+      <p:nvGrpSpPr>
+        <p:cNvPr id="1" name=""/>
+        <p:cNvGrpSpPr/>
+        <p:nvPr/>
+      </p:nvGrpSpPr>
+      <p:grpSpPr>
+        <a:xfrm>
+          <a:off x="0" y="0"/>
+          <a:ext cx="0" cy="0"/>
+          <a:chOff x="0" y="0"/>
+          <a:chExt cx="0" cy="0"/>
+        </a:xfrm>
+      </p:grpSpPr>
+      <p:sp>
+        <p:nvSpPr>
           <p:cNvPr id="4" name="Text Placeholder 3"/>
           <p:cNvSpPr>
             <a:spLocks noGrp="1"/>
@@ -3423,7 +3793,7 @@
 </p:sld>
 </file>
 
-<file path=ppt/slides/slide11.xml><?xml version="1.0" encoding="utf-8"?>
+<file path=ppt/slides/slide14.xml><?xml version="1.0" encoding="utf-8"?>
 <p:sld xmlns:a="http://schemas.openxmlformats.org/drawingml/2006/main" xmlns:r="http://schemas.openxmlformats.org/officeDocument/2006/relationships" xmlns:p="http://schemas.openxmlformats.org/presentationml/2006/main">
   <p:cSld>
     <p:spTree>
@@ -3518,7 +3888,7 @@
 </p:sld>
 </file>
 
-<file path=ppt/slides/slide12.xml><?xml version="1.0" encoding="utf-8"?>
+<file path=ppt/slides/slide15.xml><?xml version="1.0" encoding="utf-8"?>
 <p:sld xmlns:a="http://schemas.openxmlformats.org/drawingml/2006/main" xmlns:r="http://schemas.openxmlformats.org/officeDocument/2006/relationships" xmlns:p="http://schemas.openxmlformats.org/presentationml/2006/main">
   <p:cSld>
     <p:spTree>
@@ -3640,7 +4010,7 @@
 </p:sld>
 </file>
 
-<file path=ppt/slides/slide13.xml><?xml version="1.0" encoding="utf-8"?>
+<file path=ppt/slides/slide16.xml><?xml version="1.0" encoding="utf-8"?>
 <p:sld xmlns:a="http://schemas.openxmlformats.org/drawingml/2006/main" xmlns:r="http://schemas.openxmlformats.org/officeDocument/2006/relationships" xmlns:p="http://schemas.openxmlformats.org/presentationml/2006/main">
   <p:cSld>
     <p:spTree>
@@ -3725,7 +4095,7 @@
 </p:sld>
 </file>
 
-<file path=ppt/slides/slide14.xml><?xml version="1.0" encoding="utf-8"?>
+<file path=ppt/slides/slide17.xml><?xml version="1.0" encoding="utf-8"?>
 <p:sld xmlns:a="http://schemas.openxmlformats.org/drawingml/2006/main" xmlns:r="http://schemas.openxmlformats.org/officeDocument/2006/relationships" xmlns:p="http://schemas.openxmlformats.org/presentationml/2006/main">
   <p:cSld>
     <p:spTree>
@@ -4119,7 +4489,7 @@
 </p:sld>
 </file>
 
-<file path=ppt/slides/slide15.xml><?xml version="1.0" encoding="utf-8"?>
+<file path=ppt/slides/slide18.xml><?xml version="1.0" encoding="utf-8"?>
 <p:sld xmlns:a="http://schemas.openxmlformats.org/drawingml/2006/main" xmlns:r="http://schemas.openxmlformats.org/officeDocument/2006/relationships" xmlns:p="http://schemas.openxmlformats.org/presentationml/2006/main">
   <p:cSld>
     <p:spTree>
@@ -4166,7 +4536,7 @@
 </p:sld>
 </file>
 
-<file path=ppt/slides/slide16.xml><?xml version="1.0" encoding="utf-8"?>
+<file path=ppt/slides/slide19.xml><?xml version="1.0" encoding="utf-8"?>
 <p:sld xmlns:a="http://schemas.openxmlformats.org/drawingml/2006/main" xmlns:r="http://schemas.openxmlformats.org/officeDocument/2006/relationships" xmlns:p="http://schemas.openxmlformats.org/presentationml/2006/main">
   <p:cSld>
     <p:spTree>
@@ -4303,247 +4673,6 @@
 </p:sld>
 </file>
 
-<file path=ppt/slides/slide17.xml><?xml version="1.0" encoding="utf-8"?>
-<p:sld xmlns:a="http://schemas.openxmlformats.org/drawingml/2006/main" xmlns:r="http://schemas.openxmlformats.org/officeDocument/2006/relationships" xmlns:p="http://schemas.openxmlformats.org/presentationml/2006/main">
-  <p:cSld>
-    <p:spTree>
-      <p:nvGrpSpPr>
-        <p:cNvPr id="1" name=""/>
-        <p:cNvGrpSpPr/>
-        <p:nvPr/>
-      </p:nvGrpSpPr>
-      <p:grpSpPr>
-        <a:xfrm>
-          <a:off x="0" y="0"/>
-          <a:ext cx="0" cy="0"/>
-          <a:chOff x="0" y="0"/>
-          <a:chExt cx="0" cy="0"/>
-        </a:xfrm>
-      </p:grpSpPr>
-      <p:sp>
-        <p:nvSpPr>
-          <p:cNvPr id="3" name="Content Placeholder 2"/>
-          <p:cNvSpPr>
-            <a:spLocks noGrp="1"/>
-          </p:cNvSpPr>
-          <p:nvPr>
-            <p:ph idx="1"/>
-          </p:nvPr>
-        </p:nvSpPr>
-        <p:spPr/>
-        <p:txBody>
-          <a:bodyPr/>
-          <a:lstStyle/>
-          <a:p>
-            <a:pPr lvl="0" indent="0" marL="0">
-              <a:spcBef>
-                <a:spcPts val="3000"/>
-              </a:spcBef>
-              <a:buNone/>
-            </a:pPr>
-            <a:r>
-              <a:rPr b="1"/>
-              <a:t>١٤. التحليل</a:t>
-            </a:r>
-          </a:p>
-          <a:p>
-            <a:pPr lvl="0"/>
-            <a:r>
-              <a:rPr b="1"/>
-              <a:t>الاهتزاز ≫ التيار</a:t>
-            </a:r>
-            <a:r>
-              <a:rPr/>
-              <a:t> لكشف العطل بين اللفات — متوقّع فيزيائياً (الاهتزاز يستجيب مباشرة، وFOC يُخمد بصمة التيار).</a:t>
-            </a:r>
-          </a:p>
-          <a:p>
-            <a:pPr lvl="0"/>
-            <a:r>
-              <a:rPr b="1"/>
-              <a:t>الدمج</a:t>
-            </a:r>
-            <a:r>
-              <a:rPr/>
-              <a:t> يتفوّق على التيار وحده لكن ليس على الاهتزاز وحده.</a:t>
-            </a:r>
-          </a:p>
-          <a:p>
-            <a:pPr lvl="0"/>
-            <a:r>
-              <a:rPr b="1"/>
-              <a:t>اختيار المقياس مهم</a:t>
-            </a:r>
-            <a:r>
-              <a:rPr/>
-              <a:t>: الدقة المتوازنة كشفت انهيار صنف الأغلبية الذي تُخفيه الدقة الخام.</a:t>
-            </a:r>
-          </a:p>
-        </p:txBody>
-      </p:sp>
-    </p:spTree>
-  </p:cSld>
-</p:sld>
-</file>
-
-<file path=ppt/slides/slide18.xml><?xml version="1.0" encoding="utf-8"?>
-<p:sld xmlns:a="http://schemas.openxmlformats.org/drawingml/2006/main" xmlns:r="http://schemas.openxmlformats.org/officeDocument/2006/relationships" xmlns:p="http://schemas.openxmlformats.org/presentationml/2006/main">
-  <p:cSld>
-    <p:spTree>
-      <p:nvGrpSpPr>
-        <p:cNvPr id="1" name=""/>
-        <p:cNvGrpSpPr/>
-        <p:nvPr/>
-      </p:nvGrpSpPr>
-      <p:grpSpPr>
-        <a:xfrm>
-          <a:off x="0" y="0"/>
-          <a:ext cx="0" cy="0"/>
-          <a:chOff x="0" y="0"/>
-          <a:chExt cx="0" cy="0"/>
-        </a:xfrm>
-      </p:grpSpPr>
-      <p:sp>
-        <p:nvSpPr>
-          <p:cNvPr id="3" name="Content Placeholder 2"/>
-          <p:cNvSpPr>
-            <a:spLocks noGrp="1"/>
-          </p:cNvSpPr>
-          <p:nvPr>
-            <p:ph idx="1"/>
-          </p:nvPr>
-        </p:nvSpPr>
-        <p:spPr/>
-        <p:txBody>
-          <a:bodyPr/>
-          <a:lstStyle/>
-          <a:p>
-            <a:pPr lvl="0" indent="0" marL="0">
-              <a:spcBef>
-                <a:spcPts val="3000"/>
-              </a:spcBef>
-              <a:buNone/>
-            </a:pPr>
-            <a:r>
-              <a:rPr b="1"/>
-              <a:t>١٥. تجارب التحسين</a:t>
-            </a:r>
-          </a:p>
-          <a:p>
-            <a:pPr lvl="0"/>
-            <a:r>
-              <a:rPr b="1"/>
-              <a:t>الموازنة</a:t>
-            </a:r>
-            <a:r>
-              <a:rPr/>
-              <a:t> تمنع انهيار الأغلبية (استدعاء السليم للتيار 0.00 ⟵ 1.00).</a:t>
-            </a:r>
-          </a:p>
-          <a:p>
-            <a:pPr lvl="0"/>
-            <a:r>
-              <a:rPr b="1"/>
-              <a:t>حجم الصورة</a:t>
-            </a:r>
-            <a:r>
-              <a:rPr/>
-              <a:t>: يُحسّن التيار تدريجياً (0.68→0.76 من 96 إلى 224)؛ الاهتزاز مُشبَع.</a:t>
-            </a:r>
-          </a:p>
-          <a:p>
-            <a:pPr lvl="0"/>
-            <a:r>
-              <a:rPr b="1"/>
-              <a:t>منحنى التعلّم</a:t>
-            </a:r>
-            <a:r>
-              <a:rPr/>
-              <a:t>: الاهتزاز يكفيه ~46 صورة؛ التيار ثابت ~0.70 مهما زادت البيانات ⟵ القيد جودة الإشارة لا كميّتها.</a:t>
-            </a:r>
-          </a:p>
-        </p:txBody>
-      </p:sp>
-    </p:spTree>
-  </p:cSld>
-</p:sld>
-</file>
-
-<file path=ppt/slides/slide19.xml><?xml version="1.0" encoding="utf-8"?>
-<p:sld xmlns:a="http://schemas.openxmlformats.org/drawingml/2006/main" xmlns:r="http://schemas.openxmlformats.org/officeDocument/2006/relationships" xmlns:p="http://schemas.openxmlformats.org/presentationml/2006/main">
-  <p:cSld>
-    <p:spTree>
-      <p:nvGrpSpPr>
-        <p:cNvPr id="1" name=""/>
-        <p:cNvGrpSpPr/>
-        <p:nvPr/>
-      </p:nvGrpSpPr>
-      <p:grpSpPr>
-        <a:xfrm>
-          <a:off x="0" y="0"/>
-          <a:ext cx="0" cy="0"/>
-          <a:chOff x="0" y="0"/>
-          <a:chExt cx="0" cy="0"/>
-        </a:xfrm>
-      </p:grpSpPr>
-      <p:sp>
-        <p:nvSpPr>
-          <p:cNvPr id="3" name="Content Placeholder 2"/>
-          <p:cNvSpPr>
-            <a:spLocks noGrp="1"/>
-          </p:cNvSpPr>
-          <p:nvPr>
-            <p:ph idx="1"/>
-          </p:nvPr>
-        </p:nvSpPr>
-        <p:spPr/>
-        <p:txBody>
-          <a:bodyPr/>
-          <a:lstStyle/>
-          <a:p>
-            <a:pPr lvl="0" indent="0" marL="0">
-              <a:spcBef>
-                <a:spcPts val="3000"/>
-              </a:spcBef>
-              <a:buNone/>
-            </a:pPr>
-            <a:r>
-              <a:rPr b="1"/>
-              <a:t>١٦. القيود</a:t>
-            </a:r>
-          </a:p>
-          <a:p>
-            <a:pPr lvl="0"/>
-            <a:r>
-              <a:rPr b="1"/>
-              <a:t>4 تسجيلات سليمة فقط</a:t>
-            </a:r>
-            <a:r>
-              <a:rPr/>
-              <a:t> ⟵ النتيجة المثالية للاهتزاز لا تستبعد تماماً تعلّم “هوية التسجيل”.</a:t>
-            </a:r>
-          </a:p>
-          <a:p>
-            <a:pPr lvl="0"/>
-            <a:r>
-              <a:rPr/>
-              <a:t>إزالة المغنطة والحمل الزائد اصطناعية فقط.</a:t>
-            </a:r>
-          </a:p>
-          <a:p>
-            <a:pPr lvl="0"/>
-            <a:r>
-              <a:rPr/>
-              <a:t>مقارنة الدمج إرشادية لا مضبوطة بدقّة.</a:t>
-            </a:r>
-          </a:p>
-        </p:txBody>
-      </p:sp>
-    </p:spTree>
-  </p:cSld>
-</p:sld>
-</file>
-
 <file path=ppt/slides/slide2.xml><?xml version="1.0" encoding="utf-8"?>
 <p:sld xmlns:a="http://schemas.openxmlformats.org/drawingml/2006/main" xmlns:r="http://schemas.openxmlformats.org/officeDocument/2006/relationships" xmlns:p="http://schemas.openxmlformats.org/presentationml/2006/main">
   <p:cSld>
@@ -4706,29 +4835,40 @@
             </a:pPr>
             <a:r>
               <a:rPr b="1"/>
-              <a:t>١٧. الخلاصة والعمل المستقبلي</a:t>
+              <a:t>١٤. التحليل</a:t>
             </a:r>
           </a:p>
           <a:p>
             <a:pPr lvl="0"/>
             <a:r>
-              <a:rPr/>
-              <a:t>منظومة scalogram + CNN قابلة للتكرار تكشف الأعطال بين اللفات؛ </a:t>
-            </a:r>
-            <a:r>
-              <a:rPr b="1"/>
-              <a:t>الاهتزاز يبلغ دقة متوازنة 1.00</a:t>
-            </a:r>
-            <a:r>
-              <a:rPr/>
-              <a:t> على تسجيلات محجوزة.</a:t>
+              <a:rPr b="1"/>
+              <a:t>الاهتزاز ≫ التيار</a:t>
+            </a:r>
+            <a:r>
+              <a:rPr/>
+              <a:t> لكشف العطل بين اللفات — متوقّع فيزيائياً (الاهتزاز يستجيب مباشرة، وFOC يُخمد بصمة التيار).</a:t>
             </a:r>
           </a:p>
           <a:p>
             <a:pPr lvl="0"/>
             <a:r>
-              <a:rPr/>
-              <a:t>مستقبلاً: تسجيلات مستقلّة أكثر؛ مجموعة دمج متعدّدة القنوات متزامنة؛ تصنيف حسب الشدّة؛ التفسيرية (Grad-CAM)؛ النشر اللحظي داخل المُشغّل.</a:t>
+              <a:rPr b="1"/>
+              <a:t>الدمج</a:t>
+            </a:r>
+            <a:r>
+              <a:rPr/>
+              <a:t> يتفوّق على التيار وحده لكن ليس على الاهتزاز وحده.</a:t>
+            </a:r>
+          </a:p>
+          <a:p>
+            <a:pPr lvl="0"/>
+            <a:r>
+              <a:rPr b="1"/>
+              <a:t>اختيار المقياس مهم</a:t>
+            </a:r>
+            <a:r>
+              <a:rPr/>
+              <a:t>: الدقة المتوازنة كشفت انهيار صنف الأغلبية الذي تُخفيه الدقة الخام.</a:t>
             </a:r>
           </a:p>
         </p:txBody>
@@ -4757,6 +4897,236 @@
       </p:grpSpPr>
       <p:sp>
         <p:nvSpPr>
+          <p:cNvPr id="3" name="Content Placeholder 2"/>
+          <p:cNvSpPr>
+            <a:spLocks noGrp="1"/>
+          </p:cNvSpPr>
+          <p:nvPr>
+            <p:ph idx="1"/>
+          </p:nvPr>
+        </p:nvSpPr>
+        <p:spPr/>
+        <p:txBody>
+          <a:bodyPr/>
+          <a:lstStyle/>
+          <a:p>
+            <a:pPr lvl="0" indent="0" marL="0">
+              <a:spcBef>
+                <a:spcPts val="3000"/>
+              </a:spcBef>
+              <a:buNone/>
+            </a:pPr>
+            <a:r>
+              <a:rPr b="1"/>
+              <a:t>١٥. تجارب التحسين</a:t>
+            </a:r>
+          </a:p>
+          <a:p>
+            <a:pPr lvl="0"/>
+            <a:r>
+              <a:rPr b="1"/>
+              <a:t>الموازنة</a:t>
+            </a:r>
+            <a:r>
+              <a:rPr/>
+              <a:t> تمنع انهيار الأغلبية (استدعاء السليم للتيار 0.00 ⟵ 1.00).</a:t>
+            </a:r>
+          </a:p>
+          <a:p>
+            <a:pPr lvl="0"/>
+            <a:r>
+              <a:rPr b="1"/>
+              <a:t>حجم الصورة</a:t>
+            </a:r>
+            <a:r>
+              <a:rPr/>
+              <a:t>: يُحسّن التيار تدريجياً (0.68→0.76 من 96 إلى 224)؛ الاهتزاز مُشبَع.</a:t>
+            </a:r>
+          </a:p>
+          <a:p>
+            <a:pPr lvl="0"/>
+            <a:r>
+              <a:rPr b="1"/>
+              <a:t>منحنى التعلّم</a:t>
+            </a:r>
+            <a:r>
+              <a:rPr/>
+              <a:t>: الاهتزاز يكفيه ~46 صورة؛ التيار ثابت ~0.70 مهما زادت البيانات ⟵ القيد جودة الإشارة لا كميّتها.</a:t>
+            </a:r>
+          </a:p>
+        </p:txBody>
+      </p:sp>
+    </p:spTree>
+  </p:cSld>
+</p:sld>
+</file>
+
+<file path=ppt/slides/slide22.xml><?xml version="1.0" encoding="utf-8"?>
+<p:sld xmlns:a="http://schemas.openxmlformats.org/drawingml/2006/main" xmlns:r="http://schemas.openxmlformats.org/officeDocument/2006/relationships" xmlns:p="http://schemas.openxmlformats.org/presentationml/2006/main">
+  <p:cSld>
+    <p:spTree>
+      <p:nvGrpSpPr>
+        <p:cNvPr id="1" name=""/>
+        <p:cNvGrpSpPr/>
+        <p:nvPr/>
+      </p:nvGrpSpPr>
+      <p:grpSpPr>
+        <a:xfrm>
+          <a:off x="0" y="0"/>
+          <a:ext cx="0" cy="0"/>
+          <a:chOff x="0" y="0"/>
+          <a:chExt cx="0" cy="0"/>
+        </a:xfrm>
+      </p:grpSpPr>
+      <p:sp>
+        <p:nvSpPr>
+          <p:cNvPr id="3" name="Content Placeholder 2"/>
+          <p:cNvSpPr>
+            <a:spLocks noGrp="1"/>
+          </p:cNvSpPr>
+          <p:nvPr>
+            <p:ph idx="1"/>
+          </p:nvPr>
+        </p:nvSpPr>
+        <p:spPr/>
+        <p:txBody>
+          <a:bodyPr/>
+          <a:lstStyle/>
+          <a:p>
+            <a:pPr lvl="0" indent="0" marL="0">
+              <a:spcBef>
+                <a:spcPts val="3000"/>
+              </a:spcBef>
+              <a:buNone/>
+            </a:pPr>
+            <a:r>
+              <a:rPr b="1"/>
+              <a:t>١٦. القيود</a:t>
+            </a:r>
+          </a:p>
+          <a:p>
+            <a:pPr lvl="0"/>
+            <a:r>
+              <a:rPr b="1"/>
+              <a:t>4 تسجيلات سليمة فقط</a:t>
+            </a:r>
+            <a:r>
+              <a:rPr/>
+              <a:t> ⟵ النتيجة المثالية للاهتزاز لا تستبعد تماماً تعلّم “هوية التسجيل”.</a:t>
+            </a:r>
+          </a:p>
+          <a:p>
+            <a:pPr lvl="0"/>
+            <a:r>
+              <a:rPr/>
+              <a:t>إزالة المغنطة والحمل الزائد اصطناعية فقط.</a:t>
+            </a:r>
+          </a:p>
+          <a:p>
+            <a:pPr lvl="0"/>
+            <a:r>
+              <a:rPr/>
+              <a:t>مقارنة الدمج إرشادية لا مضبوطة بدقّة.</a:t>
+            </a:r>
+          </a:p>
+        </p:txBody>
+      </p:sp>
+    </p:spTree>
+  </p:cSld>
+</p:sld>
+</file>
+
+<file path=ppt/slides/slide23.xml><?xml version="1.0" encoding="utf-8"?>
+<p:sld xmlns:a="http://schemas.openxmlformats.org/drawingml/2006/main" xmlns:r="http://schemas.openxmlformats.org/officeDocument/2006/relationships" xmlns:p="http://schemas.openxmlformats.org/presentationml/2006/main">
+  <p:cSld>
+    <p:spTree>
+      <p:nvGrpSpPr>
+        <p:cNvPr id="1" name=""/>
+        <p:cNvGrpSpPr/>
+        <p:nvPr/>
+      </p:nvGrpSpPr>
+      <p:grpSpPr>
+        <a:xfrm>
+          <a:off x="0" y="0"/>
+          <a:ext cx="0" cy="0"/>
+          <a:chOff x="0" y="0"/>
+          <a:chExt cx="0" cy="0"/>
+        </a:xfrm>
+      </p:grpSpPr>
+      <p:sp>
+        <p:nvSpPr>
+          <p:cNvPr id="3" name="Content Placeholder 2"/>
+          <p:cNvSpPr>
+            <a:spLocks noGrp="1"/>
+          </p:cNvSpPr>
+          <p:nvPr>
+            <p:ph idx="1"/>
+          </p:nvPr>
+        </p:nvSpPr>
+        <p:spPr/>
+        <p:txBody>
+          <a:bodyPr/>
+          <a:lstStyle/>
+          <a:p>
+            <a:pPr lvl="0" indent="0" marL="0">
+              <a:spcBef>
+                <a:spcPts val="3000"/>
+              </a:spcBef>
+              <a:buNone/>
+            </a:pPr>
+            <a:r>
+              <a:rPr b="1"/>
+              <a:t>١٧. الخلاصة والعمل المستقبلي</a:t>
+            </a:r>
+          </a:p>
+          <a:p>
+            <a:pPr lvl="0"/>
+            <a:r>
+              <a:rPr/>
+              <a:t>منظومة scalogram + CNN قابلة للتكرار تكشف الأعطال بين اللفات؛ </a:t>
+            </a:r>
+            <a:r>
+              <a:rPr b="1"/>
+              <a:t>الاهتزاز يبلغ دقة متوازنة 1.00</a:t>
+            </a:r>
+            <a:r>
+              <a:rPr/>
+              <a:t> على تسجيلات محجوزة.</a:t>
+            </a:r>
+          </a:p>
+          <a:p>
+            <a:pPr lvl="0"/>
+            <a:r>
+              <a:rPr/>
+              <a:t>مستقبلاً: تسجيلات مستقلّة أكثر؛ مجموعة دمج متعدّدة القنوات متزامنة؛ تصنيف حسب الشدّة؛ التفسيرية (Grad-CAM)؛ النشر اللحظي داخل المُشغّل.</a:t>
+            </a:r>
+          </a:p>
+        </p:txBody>
+      </p:sp>
+    </p:spTree>
+  </p:cSld>
+</p:sld>
+</file>
+
+<file path=ppt/slides/slide24.xml><?xml version="1.0" encoding="utf-8"?>
+<p:sld xmlns:a="http://schemas.openxmlformats.org/drawingml/2006/main" xmlns:r="http://schemas.openxmlformats.org/officeDocument/2006/relationships" xmlns:p="http://schemas.openxmlformats.org/presentationml/2006/main">
+  <p:cSld>
+    <p:spTree>
+      <p:nvGrpSpPr>
+        <p:cNvPr id="1" name=""/>
+        <p:cNvGrpSpPr/>
+        <p:nvPr/>
+      </p:nvGrpSpPr>
+      <p:grpSpPr>
+        <a:xfrm>
+          <a:off x="0" y="0"/>
+          <a:ext cx="0" cy="0"/>
+          <a:chOff x="0" y="0"/>
+          <a:chExt cx="0" cy="0"/>
+        </a:xfrm>
+      </p:grpSpPr>
+      <p:sp>
+        <p:nvSpPr>
           <p:cNvPr id="2" name="Title 1"/>
           <p:cNvSpPr>
             <a:spLocks noGrp="1"/>
@@ -5275,12 +5645,12 @@
       </p:grpSpPr>
       <p:sp>
         <p:nvSpPr>
-          <p:cNvPr id="3" name="Content Placeholder 2"/>
-          <p:cNvSpPr>
-            <a:spLocks noGrp="1"/>
-          </p:cNvSpPr>
-          <p:nvPr>
-            <p:ph idx="1"/>
+          <p:cNvPr id="4" name="Text Placeholder 3"/>
+          <p:cNvSpPr>
+            <a:spLocks noGrp="1"/>
+          </p:cNvSpPr>
+          <p:nvPr>
+            <p:ph idx="2" sz="half" type="body"/>
           </p:nvPr>
         </p:nvSpPr>
         <p:spPr/>
@@ -5296,73 +5666,130 @@
             </a:pPr>
             <a:r>
               <a:rPr b="1"/>
-              <a:t>٥. لماذا المويجات وليس فورييه؟</a:t>
-            </a:r>
-          </a:p>
+              <a:t>المحرك ونظام التحكّم</a:t>
+            </a:r>
+          </a:p>
+        </p:txBody>
+      </p:sp>
+      <p:pic>
+        <p:nvPicPr>
+          <p:cNvPr descr="../figures/fig_foc_block.png" id="0" name="Picture 1"/>
+          <p:cNvPicPr>
+            <a:picLocks noGrp="1" noChangeAspect="1"/>
+          </p:cNvPicPr>
+          <p:nvPr/>
+        </p:nvPicPr>
+        <p:blipFill>
+          <a:blip r:embed="rId2"/>
+          <a:stretch>
+            <a:fillRect/>
+          </a:stretch>
+        </p:blipFill>
+        <p:spPr bwMode="auto">
+          <a:xfrm>
+            <a:off x="3568700" y="1320800"/>
+            <a:ext cx="5105400" cy="1638300"/>
+          </a:xfrm>
+          <a:prstGeom prst="rect">
+            <a:avLst/>
+          </a:prstGeom>
+          <a:noFill/>
+          <a:ln w="9525">
+            <a:noFill/>
+            <a:headEnd/>
+            <a:tailEnd/>
+          </a:ln>
+        </p:spPr>
+      </p:pic>
+      <p:sp>
+        <p:nvSpPr>
+          <p:cNvPr id="1" name="TextBox 3"/>
+          <p:cNvSpPr txBox="1"/>
+          <p:nvPr>
+            <p:ph idx="1"/>
+          </p:nvPr>
+        </p:nvSpPr>
+        <p:spPr>
+          <a:xfrm>
+            <a:off x="3568700" y="4076700"/>
+            <a:ext cx="5105400" cy="508000"/>
+          </a:xfrm>
+          <a:prstGeom prst="rect">
+            <a:avLst/>
+          </a:prstGeom>
+          <a:noFill/>
+        </p:spPr>
+        <p:txBody>
+          <a:bodyPr/>
+          <a:lstStyle/>
+          <a:p>
+            <a:pPr lvl="0" indent="0" marL="0" algn="ctr">
+              <a:buNone/>
+            </a:pPr>
+            <a:r>
+              <a:rPr/>
+              <a:t>w:780</a:t>
+            </a:r>
+          </a:p>
+        </p:txBody>
+      </p:sp>
+      <p:sp>
+        <p:nvSpPr>
+          <p:cNvPr id="3" name="Content Placeholder 2"/>
+          <p:cNvSpPr>
+            <a:spLocks noGrp="1"/>
+          </p:cNvSpPr>
+          <p:nvPr>
+            <p:ph idx="1"/>
+          </p:nvPr>
+        </p:nvSpPr>
+        <p:spPr/>
+        <p:txBody>
+          <a:bodyPr/>
+          <a:lstStyle/>
           <a:p>
             <a:pPr lvl="0"/>
             <a:r>
               <a:rPr/>
-              <a:t>تحويل فورييه </a:t>
-            </a:r>
-            <a:r>
-              <a:rPr b="1"/>
-              <a:t>أعمى زمنياً</a:t>
-            </a:r>
-            <a:r>
-              <a:rPr/>
-              <a:t> — لا يخبرنا </a:t>
-            </a:r>
-            <a:r>
-              <a:rPr i="1"/>
-              <a:t>متى</a:t>
-            </a:r>
-            <a:r>
-              <a:rPr/>
-              <a:t> يحدث التردد.</a:t>
+              <a:t>عضو ثابت (ملف ثلاثي الطور) + عضو دوّار مغناطيسي؛ يُقاد بعاكس تحت </a:t>
+            </a:r>
+            <a:r>
+              <a:rPr b="1"/>
+              <a:t>FOC</a:t>
+            </a:r>
+            <a:r>
+              <a:rPr/>
+              <a:t>.</a:t>
             </a:r>
           </a:p>
           <a:p>
             <a:pPr lvl="0"/>
             <a:r>
               <a:rPr/>
-              <a:t>إشارات الأعطال </a:t>
-            </a:r>
-            <a:r>
-              <a:rPr b="1"/>
-              <a:t>غير مستقرة</a:t>
-            </a:r>
-            <a:r>
-              <a:rPr/>
-              <a:t> (عابرة، تعتمد على الحمل).</a:t>
+              <a:t>حلقة التيّار </a:t>
+            </a:r>
+            <a:r>
+              <a:rPr b="1"/>
+              <a:t>ترفض الاضطرابات ← تُخفي بصمة العطل في التيّار</a:t>
+            </a:r>
+            <a:r>
+              <a:rPr/>
+              <a:t>.</a:t>
             </a:r>
           </a:p>
           <a:p>
             <a:pPr lvl="0"/>
             <a:r>
               <a:rPr/>
-              <a:t>مبدأ عدم اليقين: </a:t>
-            </a:r>
-            <a:r>
-              <a:rPr>
-                <a:latin typeface="Courier"/>
-              </a:rPr>
-              <a:t>Δt · Δf ≥ ثابت</a:t>
-            </a:r>
-            <a:r>
-              <a:rPr/>
-              <a:t> — يستحيل دقّة زمنية وترددية مثاليّتان معاً.</a:t>
-            </a:r>
-          </a:p>
-          <a:p>
-            <a:pPr lvl="0"/>
-            <a:r>
-              <a:rPr b="1"/>
-              <a:t>المويجات</a:t>
-            </a:r>
-            <a:r>
-              <a:rPr/>
-              <a:t> = موجات قصيرة موضعية ⟵ دقّة ترددية متغيّرة، مثاليّة للظواهر العابرة.</a:t>
+              <a:t>ولهذا </a:t>
+            </a:r>
+            <a:r>
+              <a:rPr b="1"/>
+              <a:t>يكشف الاهتزاز القِصَر بين اللفّات أفضل بكثير</a:t>
+            </a:r>
+            <a:r>
+              <a:rPr/>
+              <a:t> (نتيجتنا الأساسية).</a:t>
             </a:r>
           </a:p>
         </p:txBody>
@@ -5391,12 +5818,12 @@
       </p:grpSpPr>
       <p:sp>
         <p:nvSpPr>
-          <p:cNvPr id="3" name="Content Placeholder 2"/>
-          <p:cNvSpPr>
-            <a:spLocks noGrp="1"/>
-          </p:cNvSpPr>
-          <p:nvPr>
-            <p:ph idx="1"/>
+          <p:cNvPr id="4" name="Text Placeholder 3"/>
+          <p:cNvSpPr>
+            <a:spLocks noGrp="1"/>
+          </p:cNvSpPr>
+          <p:nvPr>
+            <p:ph idx="2" sz="half" type="body"/>
           </p:nvPr>
         </p:nvSpPr>
         <p:spPr/>
@@ -5412,63 +5839,130 @@
             </a:pPr>
             <a:r>
               <a:rPr b="1"/>
-              <a:t>٦. تحويل المويجات المستمر (CWT) ومخطط الطيف</a:t>
-            </a:r>
-          </a:p>
+              <a:t>PMSM مقابل نظائره</a:t>
+            </a:r>
+          </a:p>
+        </p:txBody>
+      </p:sp>
+      <p:pic>
+        <p:nvPicPr>
+          <p:cNvPr descr="../figures/fig_motor_comparison.png" id="0" name="Picture 1"/>
+          <p:cNvPicPr>
+            <a:picLocks noGrp="1" noChangeAspect="1"/>
+          </p:cNvPicPr>
+          <p:nvPr/>
+        </p:nvPicPr>
+        <p:blipFill>
+          <a:blip r:embed="rId2"/>
+          <a:stretch>
+            <a:fillRect/>
+          </a:stretch>
+        </p:blipFill>
+        <p:spPr bwMode="auto">
+          <a:xfrm>
+            <a:off x="3568700" y="1270000"/>
+            <a:ext cx="5105400" cy="1727200"/>
+          </a:xfrm>
+          <a:prstGeom prst="rect">
+            <a:avLst/>
+          </a:prstGeom>
+          <a:noFill/>
+          <a:ln w="9525">
+            <a:noFill/>
+            <a:headEnd/>
+            <a:tailEnd/>
+          </a:ln>
+        </p:spPr>
+      </p:pic>
+      <p:sp>
+        <p:nvSpPr>
+          <p:cNvPr id="1" name="TextBox 3"/>
+          <p:cNvSpPr txBox="1"/>
+          <p:nvPr>
+            <p:ph idx="1"/>
+          </p:nvPr>
+        </p:nvSpPr>
+        <p:spPr>
+          <a:xfrm>
+            <a:off x="3568700" y="4076700"/>
+            <a:ext cx="5105400" cy="508000"/>
+          </a:xfrm>
+          <a:prstGeom prst="rect">
+            <a:avLst/>
+          </a:prstGeom>
+          <a:noFill/>
+        </p:spPr>
+        <p:txBody>
+          <a:bodyPr/>
+          <a:lstStyle/>
+          <a:p>
+            <a:pPr lvl="0" indent="0" marL="0" algn="ctr">
+              <a:buNone/>
+            </a:pPr>
+            <a:r>
+              <a:rPr/>
+              <a:t>w:880</a:t>
+            </a:r>
+          </a:p>
+        </p:txBody>
+      </p:sp>
+      <p:sp>
+        <p:nvSpPr>
+          <p:cNvPr id="3" name="Content Placeholder 2"/>
+          <p:cNvSpPr>
+            <a:spLocks noGrp="1"/>
+          </p:cNvSpPr>
+          <p:nvPr>
+            <p:ph idx="1"/>
+          </p:nvPr>
+        </p:nvSpPr>
+        <p:spPr/>
+        <p:txBody>
+          <a:bodyPr/>
+          <a:lstStyle/>
           <a:p>
             <a:pPr lvl="0"/>
             <a:r>
               <a:rPr/>
-              <a:t>نُقيّس مويجة </a:t>
-            </a:r>
-            <a:r>
-              <a:rPr b="1"/>
-              <a:t>Morlet</a:t>
-            </a:r>
-            <a:r>
-              <a:rPr/>
-              <a:t> (مقبض التردد) ونُزلقها (مقبض الزمن).</a:t>
+              <a:t>مقابل </a:t>
+            </a:r>
+            <a:r>
+              <a:rPr b="1"/>
+              <a:t>PMDC</a:t>
+            </a:r>
+            <a:r>
+              <a:rPr/>
+              <a:t>: نفس سهولة التحكّم بالعزم، لكن دون فُرَش ← صيانة أقل.</a:t>
             </a:r>
           </a:p>
           <a:p>
             <a:pPr lvl="0"/>
             <a:r>
               <a:rPr/>
-              <a:t>كلّ معامل = </a:t>
-            </a:r>
-            <a:r>
-              <a:rPr b="1"/>
-              <a:t>تشابه</a:t>
-            </a:r>
-            <a:r>
-              <a:rPr/>
-              <a:t> الإشارة مع تلك الموجة عند ذلك الزمن.</a:t>
+              <a:t>مقابل </a:t>
+            </a:r>
+            <a:r>
+              <a:rPr b="1"/>
+              <a:t>BLDC</a:t>
+            </a:r>
+            <a:r>
+              <a:rPr/>
+              <a:t>: قوة دافعة جيبية + FOC ← عزم أنعم وكفاءة أعلى.</a:t>
             </a:r>
           </a:p>
           <a:p>
             <a:pPr lvl="0"/>
             <a:r>
-              <a:rPr b="1"/>
-              <a:t>Scalogram</a:t>
-            </a:r>
-            <a:r>
-              <a:rPr/>
-              <a:t> = صورة ملوّنة للطاقة مقابل الزمن (س) والتردد (ص).</a:t>
-            </a:r>
-          </a:p>
-          <a:p>
-            <a:pPr lvl="0"/>
-            <a:r>
-              <a:rPr/>
-              <a:t>الحُزَم والنطاقات الجانبية الساطعة = بصمات العطل التي </a:t>
-            </a:r>
-            <a:r>
-              <a:rPr i="1"/>
-              <a:t>تراها</a:t>
-            </a:r>
-            <a:r>
-              <a:rPr/>
-              <a:t> الشبكة.</a:t>
+              <a:rPr/>
+              <a:t>مقابل </a:t>
+            </a:r>
+            <a:r>
+              <a:rPr b="1"/>
+              <a:t>الحثّي</a:t>
+            </a:r>
+            <a:r>
+              <a:rPr/>
+              <a:t>: لا تيّار/انزلاق في العضو الدوّار ← كفاءة وكثافة عزم أعلى.</a:t>
             </a:r>
           </a:p>
         </p:txBody>
@@ -5518,14 +6012,14 @@
             </a:pPr>
             <a:r>
               <a:rPr b="1"/>
-              <a:t>٧. أمثلة على المخططات (بيانات KAIST الحقيقية)</a:t>
+              <a:t>كشف العطل — اليوم مقابل هذا العمل</a:t>
             </a:r>
           </a:p>
         </p:txBody>
       </p:sp>
       <p:pic>
         <p:nvPicPr>
-          <p:cNvPr descr="../../results/example_scalograms_real.png" id="0" name="Picture 1"/>
+          <p:cNvPr descr="../figures/fig_detection_taxonomy.png" id="0" name="Picture 1"/>
           <p:cNvPicPr>
             <a:picLocks noGrp="1" noChangeAspect="1"/>
           </p:cNvPicPr>
@@ -5539,8 +6033,8 @@
         </p:blipFill>
         <p:spPr bwMode="auto">
           <a:xfrm>
-            <a:off x="3568700" y="1473200"/>
-            <a:ext cx="5105400" cy="1346200"/>
+            <a:off x="3568700" y="1130300"/>
+            <a:ext cx="5105400" cy="2006600"/>
           </a:xfrm>
           <a:prstGeom prst="rect">
             <a:avLst/>
@@ -5580,7 +6074,7 @@
             </a:pPr>
             <a:r>
               <a:rPr/>
-              <a:t>w:1000</a:t>
+              <a:t>w:820</a:t>
             </a:r>
           </a:p>
         </p:txBody>
@@ -5600,20 +6094,44 @@
           <a:bodyPr/>
           <a:lstStyle/>
           <a:p>
-            <a:pPr lvl="0" indent="0" marL="0">
-              <a:buNone/>
-            </a:pPr>
-            <a:r>
-              <a:rPr/>
-              <a:t>العطل بين اللفات يُثري محتوى الزمن–التردد في قناة </a:t>
-            </a:r>
-            <a:r>
-              <a:rPr b="1"/>
-              <a:t>الاهتزاز</a:t>
-            </a:r>
-            <a:r>
-              <a:rPr/>
-              <a:t> بوضوح.</a:t>
+            <a:pPr lvl="0"/>
+            <a:r>
+              <a:rPr/>
+              <a:t>يدوي/خارج الخط (حراري، </a:t>
+            </a:r>
+            <a:r>
+              <a:rPr b="1"/>
+              <a:t>Megger</a:t>
+            </a:r>
+            <a:r>
+              <a:rPr/>
+              <a:t>، موجة صاعقة) ← يتطلّب إيقافاً، دوري.</a:t>
+            </a:r>
+          </a:p>
+          <a:p>
+            <a:pPr lvl="0"/>
+            <a:r>
+              <a:rPr/>
+              <a:t>متّصل MCSA/اهتزاز FFT ← عتبات ثابتة، يخدعها الحِمل/السرعة.</a:t>
+            </a:r>
+          </a:p>
+          <a:p>
+            <a:pPr lvl="0"/>
+            <a:r>
+              <a:rPr b="1"/>
+              <a:t>مخطط CWT + CNN</a:t>
+            </a:r>
+            <a:r>
+              <a:rPr/>
+              <a:t> ← يتعلّم الخصائص، متين، يكشف </a:t>
+            </a:r>
+            <a:r>
+              <a:rPr b="1"/>
+              <a:t>أبكر</a:t>
+            </a:r>
+            <a:r>
+              <a:rPr/>
+              <a:t>.</a:t>
             </a:r>
           </a:p>
         </p:txBody>

</xml_diff>

<commit_message>
Fix figure overflow in PDFs (esp. Arabic RTL); strip Marp width hints
- docs/_figfit.tex: pandoc header — adjustbox caps every image to the text box
  (downscale only) and redefines \pandocbounded to center; wired into all PDF
  builds via -H.
- docs/_ar_pdf_prep.py: for Arabic PDFs, sanitize glyphs AND replace each image
  with a raw-LaTeX \centerline{\includegraphics[width=0.82\linewidth]} block so
  RTL/bidi can no longer flush wide figures off the page (article + --beamer).
- Makefile docs/docs-ar use the header + AR prep; build engineering-background-ar.docx.
- Stripped non-functional Marp "w:NNN" hints from slides (they leaked into pandoc
  captions as "Figure: w:780").
- Rebuilt all 10 PDFs + pptx/docx; verified figures centered/on-page in EN & AR
  (report, engineering chapter, slides).

Co-Authored-By: Claude Opus 4.8 (1M context) <noreply@anthropic.com>
</commit_message>
<xml_diff>
--- a/docs/build/slides-ar.pptx
+++ b/docs/build/slides-ar.pptx
@@ -29,6 +29,11 @@
     <p:sldId id="277" r:id="rId23"/>
     <p:sldId id="278" r:id="rId24"/>
     <p:sldId id="279" r:id="rId25"/>
+    <p:sldId id="280" r:id="rId26"/>
+    <p:sldId id="281" r:id="rId27"/>
+    <p:sldId id="282" r:id="rId28"/>
+    <p:sldId id="283" r:id="rId29"/>
+    <p:sldId id="284" r:id="rId30"/>
   </p:sldIdLst>
   <p:sldSz cx="9144000" cy="5143500" type="screen16x9"/>
   <p:notesSz cx="6858000" cy="9144000"/>
@@ -3180,81 +3185,48 @@
           <a:bodyPr/>
           <a:lstStyle/>
           <a:p>
-            <a:pPr lvl="0" indent="0" marL="0">
-              <a:spcBef>
-                <a:spcPts val="3000"/>
-              </a:spcBef>
-              <a:buNone/>
-            </a:pPr>
-            <a:r>
-              <a:rPr b="1"/>
-              <a:t>٥. لماذا المويجات وليس فورييه؟</a:t>
-            </a:r>
-          </a:p>
-          <a:p>
             <a:pPr lvl="0"/>
             <a:r>
               <a:rPr/>
-              <a:t>تحويل فورييه </a:t>
-            </a:r>
-            <a:r>
-              <a:rPr b="1"/>
-              <a:t>أعمى زمنياً</a:t>
-            </a:r>
-            <a:r>
-              <a:rPr/>
-              <a:t> — لا يخبرنا </a:t>
-            </a:r>
-            <a:r>
-              <a:rPr i="1"/>
-              <a:t>متى</a:t>
-            </a:r>
-            <a:r>
-              <a:rPr/>
-              <a:t> يحدث التردد.</a:t>
+              <a:t>مقابل </a:t>
+            </a:r>
+            <a:r>
+              <a:rPr b="1"/>
+              <a:t>PMDC</a:t>
+            </a:r>
+            <a:r>
+              <a:rPr/>
+              <a:t>: نفس سهولة التحكّم بالعزم، لكن دون فُرَش ← صيانة أقل.</a:t>
             </a:r>
           </a:p>
           <a:p>
             <a:pPr lvl="0"/>
             <a:r>
               <a:rPr/>
-              <a:t>إشارات الأعطال </a:t>
-            </a:r>
-            <a:r>
-              <a:rPr b="1"/>
-              <a:t>غير مستقرة</a:t>
-            </a:r>
-            <a:r>
-              <a:rPr/>
-              <a:t> (عابرة، تعتمد على الحمل).</a:t>
+              <a:t>مقابل </a:t>
+            </a:r>
+            <a:r>
+              <a:rPr b="1"/>
+              <a:t>BLDC</a:t>
+            </a:r>
+            <a:r>
+              <a:rPr/>
+              <a:t>: قوة دافعة جيبية + FOC ← عزم أنعم وكفاءة أعلى.</a:t>
             </a:r>
           </a:p>
           <a:p>
             <a:pPr lvl="0"/>
             <a:r>
               <a:rPr/>
-              <a:t>مبدأ عدم اليقين: </a:t>
-            </a:r>
-            <a:r>
-              <a:rPr>
-                <a:latin typeface="Courier"/>
-              </a:rPr>
-              <a:t>Δt · Δf ≥ ثابت</a:t>
-            </a:r>
-            <a:r>
-              <a:rPr/>
-              <a:t> — يستحيل دقّة زمنية وترددية مثاليّتان معاً.</a:t>
-            </a:r>
-          </a:p>
-          <a:p>
-            <a:pPr lvl="0"/>
-            <a:r>
-              <a:rPr b="1"/>
-              <a:t>المويجات</a:t>
-            </a:r>
-            <a:r>
-              <a:rPr/>
-              <a:t> = موجات قصيرة موضعية ⟵ دقّة ترددية متغيّرة، مثاليّة للظواهر العابرة.</a:t>
+              <a:t>مقابل </a:t>
+            </a:r>
+            <a:r>
+              <a:rPr b="1"/>
+              <a:t>الحثّي</a:t>
+            </a:r>
+            <a:r>
+              <a:rPr/>
+              <a:t>: لا تيّار/انزلاق في العضو الدوّار ← كفاءة وكثافة عزم أعلى.</a:t>
             </a:r>
           </a:p>
         </p:txBody>
@@ -3283,12 +3255,12 @@
       </p:grpSpPr>
       <p:sp>
         <p:nvSpPr>
-          <p:cNvPr id="3" name="Content Placeholder 2"/>
-          <p:cNvSpPr>
-            <a:spLocks noGrp="1"/>
-          </p:cNvSpPr>
-          <p:nvPr>
-            <p:ph idx="1"/>
+          <p:cNvPr id="4" name="Text Placeholder 3"/>
+          <p:cNvSpPr>
+            <a:spLocks noGrp="1"/>
+          </p:cNvSpPr>
+          <p:nvPr>
+            <p:ph idx="2" sz="half" type="body"/>
           </p:nvPr>
         </p:nvSpPr>
         <p:spPr/>
@@ -3304,67 +3276,41 @@
             </a:pPr>
             <a:r>
               <a:rPr b="1"/>
-              <a:t>٦. تحويل المويجات المستمر (CWT) ومخطط الطيف</a:t>
-            </a:r>
-          </a:p>
-          <a:p>
-            <a:pPr lvl="0"/>
-            <a:r>
-              <a:rPr/>
-              <a:t>نُقيّس مويجة </a:t>
-            </a:r>
-            <a:r>
-              <a:rPr b="1"/>
-              <a:t>Morlet</a:t>
-            </a:r>
-            <a:r>
-              <a:rPr/>
-              <a:t> (مقبض التردد) ونُزلقها (مقبض الزمن).</a:t>
-            </a:r>
-          </a:p>
-          <a:p>
-            <a:pPr lvl="0"/>
-            <a:r>
-              <a:rPr/>
-              <a:t>كلّ معامل = </a:t>
-            </a:r>
-            <a:r>
-              <a:rPr b="1"/>
-              <a:t>تشابه</a:t>
-            </a:r>
-            <a:r>
-              <a:rPr/>
-              <a:t> الإشارة مع تلك الموجة عند ذلك الزمن.</a:t>
-            </a:r>
-          </a:p>
-          <a:p>
-            <a:pPr lvl="0"/>
-            <a:r>
-              <a:rPr b="1"/>
-              <a:t>Scalogram</a:t>
-            </a:r>
-            <a:r>
-              <a:rPr/>
-              <a:t> = صورة ملوّنة للطاقة مقابل الزمن (س) والتردد (ص).</a:t>
-            </a:r>
-          </a:p>
-          <a:p>
-            <a:pPr lvl="0"/>
-            <a:r>
-              <a:rPr/>
-              <a:t>الحُزَم والنطاقات الجانبية الساطعة = بصمات العطل التي </a:t>
-            </a:r>
-            <a:r>
-              <a:rPr i="1"/>
-              <a:t>تراها</a:t>
-            </a:r>
-            <a:r>
-              <a:rPr/>
-              <a:t> الشبكة.</a:t>
-            </a:r>
-          </a:p>
-        </p:txBody>
-      </p:sp>
+              <a:t>كشف العطل — اليوم مقابل هذا العمل</a:t>
+            </a:r>
+          </a:p>
+        </p:txBody>
+      </p:sp>
+      <p:pic>
+        <p:nvPicPr>
+          <p:cNvPr descr="../figures/fig_detection_taxonomy.png" id="0" name="Picture 1"/>
+          <p:cNvPicPr>
+            <a:picLocks noGrp="1" noChangeAspect="1"/>
+          </p:cNvPicPr>
+          <p:nvPr/>
+        </p:nvPicPr>
+        <p:blipFill>
+          <a:blip r:embed="rId2"/>
+          <a:stretch>
+            <a:fillRect/>
+          </a:stretch>
+        </p:blipFill>
+        <p:spPr bwMode="auto">
+          <a:xfrm>
+            <a:off x="3568700" y="1384300"/>
+            <a:ext cx="5105400" cy="2006600"/>
+          </a:xfrm>
+          <a:prstGeom prst="rect">
+            <a:avLst/>
+          </a:prstGeom>
+          <a:noFill/>
+          <a:ln w="9525">
+            <a:noFill/>
+            <a:headEnd/>
+            <a:tailEnd/>
+          </a:ln>
+        </p:spPr>
+      </p:pic>
     </p:spTree>
   </p:cSld>
 </p:sld>
@@ -3389,6 +3335,307 @@
       </p:grpSpPr>
       <p:sp>
         <p:nvSpPr>
+          <p:cNvPr id="3" name="Content Placeholder 2"/>
+          <p:cNvSpPr>
+            <a:spLocks noGrp="1"/>
+          </p:cNvSpPr>
+          <p:nvPr>
+            <p:ph idx="1"/>
+          </p:nvPr>
+        </p:nvSpPr>
+        <p:spPr/>
+        <p:txBody>
+          <a:bodyPr/>
+          <a:lstStyle/>
+          <a:p>
+            <a:pPr lvl="0"/>
+            <a:r>
+              <a:rPr/>
+              <a:t>يدوي/خارج الخط (حراري، </a:t>
+            </a:r>
+            <a:r>
+              <a:rPr b="1"/>
+              <a:t>Megger</a:t>
+            </a:r>
+            <a:r>
+              <a:rPr/>
+              <a:t>، موجة صاعقة) ← يتطلّب إيقافاً، دوري.</a:t>
+            </a:r>
+          </a:p>
+          <a:p>
+            <a:pPr lvl="0"/>
+            <a:r>
+              <a:rPr/>
+              <a:t>متّصل MCSA/اهتزاز FFT ← عتبات ثابتة، يخدعها الحِمل/السرعة.</a:t>
+            </a:r>
+          </a:p>
+          <a:p>
+            <a:pPr lvl="0"/>
+            <a:r>
+              <a:rPr b="1"/>
+              <a:t>مخطط CWT + CNN</a:t>
+            </a:r>
+            <a:r>
+              <a:rPr/>
+              <a:t> ← يتعلّم الخصائص، متين، يكشف </a:t>
+            </a:r>
+            <a:r>
+              <a:rPr b="1"/>
+              <a:t>أبكر</a:t>
+            </a:r>
+            <a:r>
+              <a:rPr/>
+              <a:t>.</a:t>
+            </a:r>
+          </a:p>
+        </p:txBody>
+      </p:sp>
+    </p:spTree>
+  </p:cSld>
+</p:sld>
+</file>
+
+<file path=ppt/slides/slide13.xml><?xml version="1.0" encoding="utf-8"?>
+<p:sld xmlns:a="http://schemas.openxmlformats.org/drawingml/2006/main" xmlns:r="http://schemas.openxmlformats.org/officeDocument/2006/relationships" xmlns:p="http://schemas.openxmlformats.org/presentationml/2006/main">
+  <p:cSld>
+    <p:spTree>
+      <p:nvGrpSpPr>
+        <p:cNvPr id="1" name=""/>
+        <p:cNvGrpSpPr/>
+        <p:nvPr/>
+      </p:nvGrpSpPr>
+      <p:grpSpPr>
+        <a:xfrm>
+          <a:off x="0" y="0"/>
+          <a:ext cx="0" cy="0"/>
+          <a:chOff x="0" y="0"/>
+          <a:chExt cx="0" cy="0"/>
+        </a:xfrm>
+      </p:grpSpPr>
+      <p:sp>
+        <p:nvSpPr>
+          <p:cNvPr id="3" name="Content Placeholder 2"/>
+          <p:cNvSpPr>
+            <a:spLocks noGrp="1"/>
+          </p:cNvSpPr>
+          <p:nvPr>
+            <p:ph idx="1"/>
+          </p:nvPr>
+        </p:nvSpPr>
+        <p:spPr/>
+        <p:txBody>
+          <a:bodyPr/>
+          <a:lstStyle/>
+          <a:p>
+            <a:pPr lvl="0" indent="0" marL="0">
+              <a:spcBef>
+                <a:spcPts val="3000"/>
+              </a:spcBef>
+              <a:buNone/>
+            </a:pPr>
+            <a:r>
+              <a:rPr b="1"/>
+              <a:t>٥. لماذا المويجات وليس فورييه؟</a:t>
+            </a:r>
+          </a:p>
+          <a:p>
+            <a:pPr lvl="0"/>
+            <a:r>
+              <a:rPr/>
+              <a:t>تحويل فورييه </a:t>
+            </a:r>
+            <a:r>
+              <a:rPr b="1"/>
+              <a:t>أعمى زمنياً</a:t>
+            </a:r>
+            <a:r>
+              <a:rPr/>
+              <a:t> — لا يخبرنا </a:t>
+            </a:r>
+            <a:r>
+              <a:rPr i="1"/>
+              <a:t>متى</a:t>
+            </a:r>
+            <a:r>
+              <a:rPr/>
+              <a:t> يحدث التردد.</a:t>
+            </a:r>
+          </a:p>
+          <a:p>
+            <a:pPr lvl="0"/>
+            <a:r>
+              <a:rPr/>
+              <a:t>إشارات الأعطال </a:t>
+            </a:r>
+            <a:r>
+              <a:rPr b="1"/>
+              <a:t>غير مستقرة</a:t>
+            </a:r>
+            <a:r>
+              <a:rPr/>
+              <a:t> (عابرة، تعتمد على الحمل).</a:t>
+            </a:r>
+          </a:p>
+          <a:p>
+            <a:pPr lvl="0"/>
+            <a:r>
+              <a:rPr/>
+              <a:t>مبدأ عدم اليقين: </a:t>
+            </a:r>
+            <a:r>
+              <a:rPr>
+                <a:latin typeface="Courier"/>
+              </a:rPr>
+              <a:t>Δt · Δf ≥ ثابت</a:t>
+            </a:r>
+            <a:r>
+              <a:rPr/>
+              <a:t> — يستحيل دقّة زمنية وترددية مثاليّتان معاً.</a:t>
+            </a:r>
+          </a:p>
+          <a:p>
+            <a:pPr lvl="0"/>
+            <a:r>
+              <a:rPr b="1"/>
+              <a:t>المويجات</a:t>
+            </a:r>
+            <a:r>
+              <a:rPr/>
+              <a:t> = موجات قصيرة موضعية ⟵ دقّة ترددية متغيّرة، مثاليّة للظواهر العابرة.</a:t>
+            </a:r>
+          </a:p>
+        </p:txBody>
+      </p:sp>
+    </p:spTree>
+  </p:cSld>
+</p:sld>
+</file>
+
+<file path=ppt/slides/slide14.xml><?xml version="1.0" encoding="utf-8"?>
+<p:sld xmlns:a="http://schemas.openxmlformats.org/drawingml/2006/main" xmlns:r="http://schemas.openxmlformats.org/officeDocument/2006/relationships" xmlns:p="http://schemas.openxmlformats.org/presentationml/2006/main">
+  <p:cSld>
+    <p:spTree>
+      <p:nvGrpSpPr>
+        <p:cNvPr id="1" name=""/>
+        <p:cNvGrpSpPr/>
+        <p:nvPr/>
+      </p:nvGrpSpPr>
+      <p:grpSpPr>
+        <a:xfrm>
+          <a:off x="0" y="0"/>
+          <a:ext cx="0" cy="0"/>
+          <a:chOff x="0" y="0"/>
+          <a:chExt cx="0" cy="0"/>
+        </a:xfrm>
+      </p:grpSpPr>
+      <p:sp>
+        <p:nvSpPr>
+          <p:cNvPr id="3" name="Content Placeholder 2"/>
+          <p:cNvSpPr>
+            <a:spLocks noGrp="1"/>
+          </p:cNvSpPr>
+          <p:nvPr>
+            <p:ph idx="1"/>
+          </p:nvPr>
+        </p:nvSpPr>
+        <p:spPr/>
+        <p:txBody>
+          <a:bodyPr/>
+          <a:lstStyle/>
+          <a:p>
+            <a:pPr lvl="0" indent="0" marL="0">
+              <a:spcBef>
+                <a:spcPts val="3000"/>
+              </a:spcBef>
+              <a:buNone/>
+            </a:pPr>
+            <a:r>
+              <a:rPr b="1"/>
+              <a:t>٦. تحويل المويجات المستمر (CWT) ومخطط الطيف</a:t>
+            </a:r>
+          </a:p>
+          <a:p>
+            <a:pPr lvl="0"/>
+            <a:r>
+              <a:rPr/>
+              <a:t>نُقيّس مويجة </a:t>
+            </a:r>
+            <a:r>
+              <a:rPr b="1"/>
+              <a:t>Morlet</a:t>
+            </a:r>
+            <a:r>
+              <a:rPr/>
+              <a:t> (مقبض التردد) ونُزلقها (مقبض الزمن).</a:t>
+            </a:r>
+          </a:p>
+          <a:p>
+            <a:pPr lvl="0"/>
+            <a:r>
+              <a:rPr/>
+              <a:t>كلّ معامل = </a:t>
+            </a:r>
+            <a:r>
+              <a:rPr b="1"/>
+              <a:t>تشابه</a:t>
+            </a:r>
+            <a:r>
+              <a:rPr/>
+              <a:t> الإشارة مع تلك الموجة عند ذلك الزمن.</a:t>
+            </a:r>
+          </a:p>
+          <a:p>
+            <a:pPr lvl="0"/>
+            <a:r>
+              <a:rPr b="1"/>
+              <a:t>Scalogram</a:t>
+            </a:r>
+            <a:r>
+              <a:rPr/>
+              <a:t> = صورة ملوّنة للطاقة مقابل الزمن (س) والتردد (ص).</a:t>
+            </a:r>
+          </a:p>
+          <a:p>
+            <a:pPr lvl="0"/>
+            <a:r>
+              <a:rPr/>
+              <a:t>الحُزَم والنطاقات الجانبية الساطعة = بصمات العطل التي </a:t>
+            </a:r>
+            <a:r>
+              <a:rPr i="1"/>
+              <a:t>تراها</a:t>
+            </a:r>
+            <a:r>
+              <a:rPr/>
+              <a:t> الشبكة.</a:t>
+            </a:r>
+          </a:p>
+        </p:txBody>
+      </p:sp>
+    </p:spTree>
+  </p:cSld>
+</p:sld>
+</file>
+
+<file path=ppt/slides/slide15.xml><?xml version="1.0" encoding="utf-8"?>
+<p:sld xmlns:a="http://schemas.openxmlformats.org/drawingml/2006/main" xmlns:r="http://schemas.openxmlformats.org/officeDocument/2006/relationships" xmlns:p="http://schemas.openxmlformats.org/presentationml/2006/main">
+  <p:cSld>
+    <p:spTree>
+      <p:nvGrpSpPr>
+        <p:cNvPr id="1" name=""/>
+        <p:cNvGrpSpPr/>
+        <p:nvPr/>
+      </p:nvGrpSpPr>
+      <p:grpSpPr>
+        <a:xfrm>
+          <a:off x="0" y="0"/>
+          <a:ext cx="0" cy="0"/>
+          <a:chOff x="0" y="0"/>
+          <a:chExt cx="0" cy="0"/>
+        </a:xfrm>
+      </p:grpSpPr>
+      <p:sp>
+        <p:nvSpPr>
           <p:cNvPr id="4" name="Text Placeholder 3"/>
           <p:cNvSpPr>
             <a:spLocks noGrp="1"/>
@@ -3431,7 +3678,7 @@
         </p:blipFill>
         <p:spPr bwMode="auto">
           <a:xfrm>
-            <a:off x="3568700" y="1473200"/>
+            <a:off x="3568700" y="1727200"/>
             <a:ext cx="5105400" cy="1346200"/>
           </a:xfrm>
           <a:prstGeom prst="rect">
@@ -3445,77 +3692,67 @@
           </a:ln>
         </p:spPr>
       </p:pic>
-      <p:sp>
-        <p:nvSpPr>
-          <p:cNvPr id="1" name="TextBox 3"/>
-          <p:cNvSpPr txBox="1"/>
-          <p:nvPr>
-            <p:ph idx="1"/>
-          </p:nvPr>
-        </p:nvSpPr>
-        <p:spPr>
-          <a:xfrm>
-            <a:off x="3568700" y="4076700"/>
-            <a:ext cx="5105400" cy="508000"/>
-          </a:xfrm>
-          <a:prstGeom prst="rect">
-            <a:avLst/>
-          </a:prstGeom>
-          <a:noFill/>
-        </p:spPr>
-        <p:txBody>
-          <a:bodyPr/>
-          <a:lstStyle/>
-          <a:p>
-            <a:pPr lvl="0" indent="0" marL="0" algn="ctr">
-              <a:buNone/>
-            </a:pPr>
-            <a:r>
-              <a:rPr/>
-              <a:t>w:1000</a:t>
-            </a:r>
-          </a:p>
-        </p:txBody>
-      </p:sp>
-      <p:sp>
-        <p:nvSpPr>
-          <p:cNvPr id="3" name="Content Placeholder 2"/>
-          <p:cNvSpPr>
-            <a:spLocks noGrp="1"/>
-          </p:cNvSpPr>
-          <p:nvPr>
-            <p:ph idx="1"/>
-          </p:nvPr>
-        </p:nvSpPr>
-        <p:spPr/>
-        <p:txBody>
-          <a:bodyPr/>
-          <a:lstStyle/>
-          <a:p>
-            <a:pPr lvl="0" indent="0" marL="0">
-              <a:buNone/>
-            </a:pPr>
-            <a:r>
-              <a:rPr/>
-              <a:t>العطل بين اللفات يُثري محتوى الزمن–التردد في قناة </a:t>
-            </a:r>
-            <a:r>
-              <a:rPr b="1"/>
-              <a:t>الاهتزاز</a:t>
-            </a:r>
-            <a:r>
-              <a:rPr/>
-              <a:t> بوضوح.</a:t>
-            </a:r>
-          </a:p>
-        </p:txBody>
-      </p:sp>
     </p:spTree>
   </p:cSld>
 </p:sld>
 </file>
 
-<file path=ppt/slides/slide13.xml><?xml version="1.0" encoding="utf-8"?>
+<file path=ppt/slides/slide16.xml><?xml version="1.0" encoding="utf-8"?>
+<p:sld xmlns:a="http://schemas.openxmlformats.org/drawingml/2006/main" xmlns:r="http://schemas.openxmlformats.org/officeDocument/2006/relationships" xmlns:p="http://schemas.openxmlformats.org/presentationml/2006/main">
+  <p:cSld>
+    <p:spTree>
+      <p:nvGrpSpPr>
+        <p:cNvPr id="1" name=""/>
+        <p:cNvGrpSpPr/>
+        <p:nvPr/>
+      </p:nvGrpSpPr>
+      <p:grpSpPr>
+        <a:xfrm>
+          <a:off x="0" y="0"/>
+          <a:ext cx="0" cy="0"/>
+          <a:chOff x="0" y="0"/>
+          <a:chExt cx="0" cy="0"/>
+        </a:xfrm>
+      </p:grpSpPr>
+      <p:sp>
+        <p:nvSpPr>
+          <p:cNvPr id="3" name="Content Placeholder 2"/>
+          <p:cNvSpPr>
+            <a:spLocks noGrp="1"/>
+          </p:cNvSpPr>
+          <p:nvPr>
+            <p:ph idx="1"/>
+          </p:nvPr>
+        </p:nvSpPr>
+        <p:spPr/>
+        <p:txBody>
+          <a:bodyPr/>
+          <a:lstStyle/>
+          <a:p>
+            <a:pPr lvl="0" indent="0" marL="0">
+              <a:buNone/>
+            </a:pPr>
+            <a:r>
+              <a:rPr/>
+              <a:t>العطل بين اللفات يُثري محتوى الزمن–التردد في قناة </a:t>
+            </a:r>
+            <a:r>
+              <a:rPr b="1"/>
+              <a:t>الاهتزاز</a:t>
+            </a:r>
+            <a:r>
+              <a:rPr/>
+              <a:t> بوضوح.</a:t>
+            </a:r>
+          </a:p>
+        </p:txBody>
+      </p:sp>
+    </p:spTree>
+  </p:cSld>
+</p:sld>
+</file>
+
+<file path=ppt/slides/slide17.xml><?xml version="1.0" encoding="utf-8"?>
 <p:sld xmlns:a="http://schemas.openxmlformats.org/drawingml/2006/main" xmlns:r="http://schemas.openxmlformats.org/officeDocument/2006/relationships" xmlns:p="http://schemas.openxmlformats.org/presentationml/2006/main">
   <p:cSld>
     <p:spTree>
@@ -3793,7 +4030,7 @@
 </p:sld>
 </file>
 
-<file path=ppt/slides/slide14.xml><?xml version="1.0" encoding="utf-8"?>
+<file path=ppt/slides/slide18.xml><?xml version="1.0" encoding="utf-8"?>
 <p:sld xmlns:a="http://schemas.openxmlformats.org/drawingml/2006/main" xmlns:r="http://schemas.openxmlformats.org/officeDocument/2006/relationships" xmlns:p="http://schemas.openxmlformats.org/presentationml/2006/main">
   <p:cSld>
     <p:spTree>
@@ -3888,7 +4125,7 @@
 </p:sld>
 </file>
 
-<file path=ppt/slides/slide15.xml><?xml version="1.0" encoding="utf-8"?>
+<file path=ppt/slides/slide19.xml><?xml version="1.0" encoding="utf-8"?>
 <p:sld xmlns:a="http://schemas.openxmlformats.org/drawingml/2006/main" xmlns:r="http://schemas.openxmlformats.org/officeDocument/2006/relationships" xmlns:p="http://schemas.openxmlformats.org/presentationml/2006/main">
   <p:cSld>
     <p:spTree>
@@ -4010,7 +4247,7 @@
 </p:sld>
 </file>
 
-<file path=ppt/slides/slide16.xml><?xml version="1.0" encoding="utf-8"?>
+<file path=ppt/slides/slide2.xml><?xml version="1.0" encoding="utf-8"?>
 <p:sld xmlns:a="http://schemas.openxmlformats.org/drawingml/2006/main" xmlns:r="http://schemas.openxmlformats.org/officeDocument/2006/relationships" xmlns:p="http://schemas.openxmlformats.org/presentationml/2006/main">
   <p:cSld>
     <p:spTree>
@@ -4029,6 +4266,128 @@
       </p:grpSpPr>
       <p:sp>
         <p:nvSpPr>
+          <p:cNvPr id="2" name="Title 1"/>
+          <p:cNvSpPr>
+            <a:spLocks noGrp="1"/>
+          </p:cNvSpPr>
+          <p:nvPr>
+            <p:ph type="title"/>
+          </p:nvPr>
+        </p:nvSpPr>
+        <p:spPr/>
+        <p:txBody>
+          <a:bodyPr/>
+          <a:lstStyle/>
+          <a:p>
+            <a:pPr lvl="0" indent="0" marL="0">
+              <a:buNone/>
+            </a:pPr>
+            <a:r>
+              <a:rPr/>
+              <a:t>استخدام الشبكات العصبية الالتفافية (CNN) لتحليل صور Wavelet Scalogram في تشخيص أعطال محركات PMSM</a:t>
+            </a:r>
+          </a:p>
+        </p:txBody>
+      </p:sp>
+      <p:sp>
+        <p:nvSpPr>
+          <p:cNvPr id="3" name="Content Placeholder 2"/>
+          <p:cNvSpPr>
+            <a:spLocks noGrp="1"/>
+          </p:cNvSpPr>
+          <p:nvPr>
+            <p:ph idx="1"/>
+          </p:nvPr>
+        </p:nvSpPr>
+        <p:spPr/>
+        <p:txBody>
+          <a:bodyPr/>
+          <a:lstStyle/>
+          <a:p>
+            <a:pPr lvl="0" indent="0" marL="0">
+              <a:buNone/>
+            </a:pPr>
+            <a:r>
+              <a:rPr b="1"/>
+              <a:t>«اسم الجامعة — الكلية»</a:t>
+            </a:r>
+            <a:r>
+              <a:rPr/>
+              <a:t> · </a:t>
+            </a:r>
+            <a:r>
+              <a:rPr b="1"/>
+              <a:t>«القسم / الاختصاص»</a:t>
+            </a:r>
+          </a:p>
+          <a:p>
+            <a:pPr lvl="0" indent="0" marL="0">
+              <a:buNone/>
+            </a:pPr>
+            <a:r>
+              <a:rPr/>
+              <a:t>إعداد الطالبين: </a:t>
+            </a:r>
+            <a:r>
+              <a:rPr b="1"/>
+              <a:t>ملهم فتنة</a:t>
+            </a:r>
+            <a:r>
+              <a:rPr/>
+              <a:t> · </a:t>
+            </a:r>
+            <a:r>
+              <a:rPr b="1"/>
+              <a:t>محمد زين قباني</a:t>
+            </a:r>
+          </a:p>
+          <a:p>
+            <a:pPr lvl="0" indent="0" marL="0">
+              <a:buNone/>
+            </a:pPr>
+            <a:r>
+              <a:rPr/>
+              <a:t>إشراف: </a:t>
+            </a:r>
+            <a:r>
+              <a:rPr b="1"/>
+              <a:t>«د. اسم المشرف»</a:t>
+            </a:r>
+            <a:r>
+              <a:rPr/>
+              <a:t> · العام الدراسي: </a:t>
+            </a:r>
+            <a:r>
+              <a:rPr b="1"/>
+              <a:t>«2025–2026»</a:t>
+            </a:r>
+          </a:p>
+        </p:txBody>
+      </p:sp>
+    </p:spTree>
+  </p:cSld>
+</p:sld>
+</file>
+
+<file path=ppt/slides/slide20.xml><?xml version="1.0" encoding="utf-8"?>
+<p:sld xmlns:a="http://schemas.openxmlformats.org/drawingml/2006/main" xmlns:r="http://schemas.openxmlformats.org/officeDocument/2006/relationships" xmlns:p="http://schemas.openxmlformats.org/presentationml/2006/main">
+  <p:cSld>
+    <p:spTree>
+      <p:nvGrpSpPr>
+        <p:cNvPr id="1" name=""/>
+        <p:cNvGrpSpPr/>
+        <p:nvPr/>
+      </p:nvGrpSpPr>
+      <p:grpSpPr>
+        <a:xfrm>
+          <a:off x="0" y="0"/>
+          <a:ext cx="0" cy="0"/>
+          <a:chOff x="0" y="0"/>
+          <a:chExt cx="0" cy="0"/>
+        </a:xfrm>
+      </p:grpSpPr>
+      <p:sp>
+        <p:nvSpPr>
           <p:cNvPr id="3" name="Content Placeholder 2"/>
           <p:cNvSpPr>
             <a:spLocks noGrp="1"/>
@@ -4095,7 +4454,7 @@
 </p:sld>
 </file>
 
-<file path=ppt/slides/slide17.xml><?xml version="1.0" encoding="utf-8"?>
+<file path=ppt/slides/slide21.xml><?xml version="1.0" encoding="utf-8"?>
 <p:sld xmlns:a="http://schemas.openxmlformats.org/drawingml/2006/main" xmlns:r="http://schemas.openxmlformats.org/officeDocument/2006/relationships" xmlns:p="http://schemas.openxmlformats.org/presentationml/2006/main">
   <p:cSld>
     <p:spTree>
@@ -4489,478 +4848,6 @@
 </p:sld>
 </file>
 
-<file path=ppt/slides/slide18.xml><?xml version="1.0" encoding="utf-8"?>
-<p:sld xmlns:a="http://schemas.openxmlformats.org/drawingml/2006/main" xmlns:r="http://schemas.openxmlformats.org/officeDocument/2006/relationships" xmlns:p="http://schemas.openxmlformats.org/presentationml/2006/main">
-  <p:cSld>
-    <p:spTree>
-      <p:nvGrpSpPr>
-        <p:cNvPr id="1" name=""/>
-        <p:cNvGrpSpPr/>
-        <p:nvPr/>
-      </p:nvGrpSpPr>
-      <p:grpSpPr>
-        <a:xfrm>
-          <a:off x="0" y="0"/>
-          <a:ext cx="0" cy="0"/>
-          <a:chOff x="0" y="0"/>
-          <a:chExt cx="0" cy="0"/>
-        </a:xfrm>
-      </p:grpSpPr>
-      <p:sp>
-        <p:nvSpPr>
-          <p:cNvPr id="3" name="Content Placeholder 2"/>
-          <p:cNvSpPr>
-            <a:spLocks noGrp="1"/>
-          </p:cNvSpPr>
-          <p:nvPr>
-            <p:ph idx="1"/>
-          </p:nvPr>
-        </p:nvSpPr>
-        <p:spPr/>
-        <p:txBody>
-          <a:bodyPr/>
-          <a:lstStyle/>
-          <a:p>
-            <a:pPr lvl="0" indent="0" marL="0">
-              <a:buNone/>
-            </a:pPr>
-            <a:r>
-              <a:rPr/>
-              <a:t>تسجيلات محجوزة للاختبار، التمييز: سليم مقابل عطل بين اللفات.</a:t>
-            </a:r>
-          </a:p>
-        </p:txBody>
-      </p:sp>
-    </p:spTree>
-  </p:cSld>
-</p:sld>
-</file>
-
-<file path=ppt/slides/slide19.xml><?xml version="1.0" encoding="utf-8"?>
-<p:sld xmlns:a="http://schemas.openxmlformats.org/drawingml/2006/main" xmlns:r="http://schemas.openxmlformats.org/officeDocument/2006/relationships" xmlns:p="http://schemas.openxmlformats.org/presentationml/2006/main">
-  <p:cSld>
-    <p:spTree>
-      <p:nvGrpSpPr>
-        <p:cNvPr id="1" name=""/>
-        <p:cNvGrpSpPr/>
-        <p:nvPr/>
-      </p:nvGrpSpPr>
-      <p:grpSpPr>
-        <a:xfrm>
-          <a:off x="0" y="0"/>
-          <a:ext cx="0" cy="0"/>
-          <a:chOff x="0" y="0"/>
-          <a:chExt cx="0" cy="0"/>
-        </a:xfrm>
-      </p:grpSpPr>
-      <p:sp>
-        <p:nvSpPr>
-          <p:cNvPr id="4" name="Text Placeholder 3"/>
-          <p:cNvSpPr>
-            <a:spLocks noGrp="1"/>
-          </p:cNvSpPr>
-          <p:nvPr>
-            <p:ph idx="2" sz="half" type="body"/>
-          </p:nvPr>
-        </p:nvSpPr>
-        <p:spPr/>
-        <p:txBody>
-          <a:bodyPr/>
-          <a:lstStyle/>
-          <a:p>
-            <a:pPr lvl="0" indent="0" marL="0">
-              <a:spcBef>
-                <a:spcPts val="3000"/>
-              </a:spcBef>
-              <a:buNone/>
-            </a:pPr>
-            <a:r>
-              <a:rPr b="1"/>
-              <a:t>١٣. مصفوفات الالتباس</a:t>
-            </a:r>
-          </a:p>
-        </p:txBody>
-      </p:sp>
-      <p:pic>
-        <p:nvPicPr>
-          <p:cNvPr descr="../../results/confusion_real_2class.png" id="0" name="Picture 1"/>
-          <p:cNvPicPr>
-            <a:picLocks noGrp="1" noChangeAspect="1"/>
-          </p:cNvPicPr>
-          <p:nvPr/>
-        </p:nvPicPr>
-        <p:blipFill>
-          <a:blip r:embed="rId2"/>
-          <a:stretch>
-            <a:fillRect/>
-          </a:stretch>
-        </p:blipFill>
-        <p:spPr bwMode="auto">
-          <a:xfrm>
-            <a:off x="3568700" y="876300"/>
-            <a:ext cx="5105400" cy="2540000"/>
-          </a:xfrm>
-          <a:prstGeom prst="rect">
-            <a:avLst/>
-          </a:prstGeom>
-          <a:noFill/>
-          <a:ln w="9525">
-            <a:noFill/>
-            <a:headEnd/>
-            <a:tailEnd/>
-          </a:ln>
-        </p:spPr>
-      </p:pic>
-      <p:sp>
-        <p:nvSpPr>
-          <p:cNvPr id="1" name="TextBox 3"/>
-          <p:cNvSpPr txBox="1"/>
-          <p:nvPr>
-            <p:ph idx="1"/>
-          </p:nvPr>
-        </p:nvSpPr>
-        <p:spPr>
-          <a:xfrm>
-            <a:off x="3568700" y="4076700"/>
-            <a:ext cx="5105400" cy="508000"/>
-          </a:xfrm>
-          <a:prstGeom prst="rect">
-            <a:avLst/>
-          </a:prstGeom>
-          <a:noFill/>
-        </p:spPr>
-        <p:txBody>
-          <a:bodyPr/>
-          <a:lstStyle/>
-          <a:p>
-            <a:pPr lvl="0" indent="0" marL="0" algn="ctr">
-              <a:buNone/>
-            </a:pPr>
-            <a:r>
-              <a:rPr/>
-              <a:t>w:900</a:t>
-            </a:r>
-          </a:p>
-        </p:txBody>
-      </p:sp>
-      <p:sp>
-        <p:nvSpPr>
-          <p:cNvPr id="3" name="Content Placeholder 2"/>
-          <p:cNvSpPr>
-            <a:spLocks noGrp="1"/>
-          </p:cNvSpPr>
-          <p:nvPr>
-            <p:ph idx="1"/>
-          </p:nvPr>
-        </p:nvSpPr>
-        <p:spPr/>
-        <p:txBody>
-          <a:bodyPr/>
-          <a:lstStyle/>
-          <a:p>
-            <a:pPr lvl="0" indent="0" marL="0">
-              <a:buNone/>
-            </a:pPr>
-            <a:r>
-              <a:rPr/>
-              <a:t>الاهتزاز مثالي؛ التيار يُخطئ معظم الأعطال؛ الدمج بينهما.</a:t>
-            </a:r>
-          </a:p>
-        </p:txBody>
-      </p:sp>
-    </p:spTree>
-  </p:cSld>
-</p:sld>
-</file>
-
-<file path=ppt/slides/slide2.xml><?xml version="1.0" encoding="utf-8"?>
-<p:sld xmlns:a="http://schemas.openxmlformats.org/drawingml/2006/main" xmlns:r="http://schemas.openxmlformats.org/officeDocument/2006/relationships" xmlns:p="http://schemas.openxmlformats.org/presentationml/2006/main">
-  <p:cSld>
-    <p:spTree>
-      <p:nvGrpSpPr>
-        <p:cNvPr id="1" name=""/>
-        <p:cNvGrpSpPr/>
-        <p:nvPr/>
-      </p:nvGrpSpPr>
-      <p:grpSpPr>
-        <a:xfrm>
-          <a:off x="0" y="0"/>
-          <a:ext cx="0" cy="0"/>
-          <a:chOff x="0" y="0"/>
-          <a:chExt cx="0" cy="0"/>
-        </a:xfrm>
-      </p:grpSpPr>
-      <p:sp>
-        <p:nvSpPr>
-          <p:cNvPr id="2" name="Title 1"/>
-          <p:cNvSpPr>
-            <a:spLocks noGrp="1"/>
-          </p:cNvSpPr>
-          <p:nvPr>
-            <p:ph type="title"/>
-          </p:nvPr>
-        </p:nvSpPr>
-        <p:spPr/>
-        <p:txBody>
-          <a:bodyPr/>
-          <a:lstStyle/>
-          <a:p>
-            <a:pPr lvl="0" indent="0" marL="0">
-              <a:buNone/>
-            </a:pPr>
-            <a:r>
-              <a:rPr/>
-              <a:t>استخدام الشبكات العصبية الالتفافية (CNN) لتحليل صور Wavelet Scalogram في تشخيص أعطال محركات PMSM</a:t>
-            </a:r>
-          </a:p>
-        </p:txBody>
-      </p:sp>
-      <p:sp>
-        <p:nvSpPr>
-          <p:cNvPr id="3" name="Content Placeholder 2"/>
-          <p:cNvSpPr>
-            <a:spLocks noGrp="1"/>
-          </p:cNvSpPr>
-          <p:nvPr>
-            <p:ph idx="1"/>
-          </p:nvPr>
-        </p:nvSpPr>
-        <p:spPr/>
-        <p:txBody>
-          <a:bodyPr/>
-          <a:lstStyle/>
-          <a:p>
-            <a:pPr lvl="0" indent="0" marL="0">
-              <a:buNone/>
-            </a:pPr>
-            <a:r>
-              <a:rPr b="1"/>
-              <a:t>«اسم الجامعة — الكلية»</a:t>
-            </a:r>
-            <a:r>
-              <a:rPr/>
-              <a:t> · </a:t>
-            </a:r>
-            <a:r>
-              <a:rPr b="1"/>
-              <a:t>«القسم / الاختصاص»</a:t>
-            </a:r>
-          </a:p>
-          <a:p>
-            <a:pPr lvl="0" indent="0" marL="0">
-              <a:buNone/>
-            </a:pPr>
-            <a:r>
-              <a:rPr/>
-              <a:t>إعداد الطالبين: </a:t>
-            </a:r>
-            <a:r>
-              <a:rPr b="1"/>
-              <a:t>ملهم فتنة</a:t>
-            </a:r>
-            <a:r>
-              <a:rPr/>
-              <a:t> · </a:t>
-            </a:r>
-            <a:r>
-              <a:rPr b="1"/>
-              <a:t>محمد زين قباني</a:t>
-            </a:r>
-          </a:p>
-          <a:p>
-            <a:pPr lvl="0" indent="0" marL="0">
-              <a:buNone/>
-            </a:pPr>
-            <a:r>
-              <a:rPr/>
-              <a:t>إشراف: </a:t>
-            </a:r>
-            <a:r>
-              <a:rPr b="1"/>
-              <a:t>«د. اسم المشرف»</a:t>
-            </a:r>
-            <a:r>
-              <a:rPr/>
-              <a:t> · العام الدراسي: </a:t>
-            </a:r>
-            <a:r>
-              <a:rPr b="1"/>
-              <a:t>«2025–2026»</a:t>
-            </a:r>
-          </a:p>
-        </p:txBody>
-      </p:sp>
-    </p:spTree>
-  </p:cSld>
-</p:sld>
-</file>
-
-<file path=ppt/slides/slide20.xml><?xml version="1.0" encoding="utf-8"?>
-<p:sld xmlns:a="http://schemas.openxmlformats.org/drawingml/2006/main" xmlns:r="http://schemas.openxmlformats.org/officeDocument/2006/relationships" xmlns:p="http://schemas.openxmlformats.org/presentationml/2006/main">
-  <p:cSld>
-    <p:spTree>
-      <p:nvGrpSpPr>
-        <p:cNvPr id="1" name=""/>
-        <p:cNvGrpSpPr/>
-        <p:nvPr/>
-      </p:nvGrpSpPr>
-      <p:grpSpPr>
-        <a:xfrm>
-          <a:off x="0" y="0"/>
-          <a:ext cx="0" cy="0"/>
-          <a:chOff x="0" y="0"/>
-          <a:chExt cx="0" cy="0"/>
-        </a:xfrm>
-      </p:grpSpPr>
-      <p:sp>
-        <p:nvSpPr>
-          <p:cNvPr id="3" name="Content Placeholder 2"/>
-          <p:cNvSpPr>
-            <a:spLocks noGrp="1"/>
-          </p:cNvSpPr>
-          <p:nvPr>
-            <p:ph idx="1"/>
-          </p:nvPr>
-        </p:nvSpPr>
-        <p:spPr/>
-        <p:txBody>
-          <a:bodyPr/>
-          <a:lstStyle/>
-          <a:p>
-            <a:pPr lvl="0" indent="0" marL="0">
-              <a:spcBef>
-                <a:spcPts val="3000"/>
-              </a:spcBef>
-              <a:buNone/>
-            </a:pPr>
-            <a:r>
-              <a:rPr b="1"/>
-              <a:t>١٤. التحليل</a:t>
-            </a:r>
-          </a:p>
-          <a:p>
-            <a:pPr lvl="0"/>
-            <a:r>
-              <a:rPr b="1"/>
-              <a:t>الاهتزاز ≫ التيار</a:t>
-            </a:r>
-            <a:r>
-              <a:rPr/>
-              <a:t> لكشف العطل بين اللفات — متوقّع فيزيائياً (الاهتزاز يستجيب مباشرة، وFOC يُخمد بصمة التيار).</a:t>
-            </a:r>
-          </a:p>
-          <a:p>
-            <a:pPr lvl="0"/>
-            <a:r>
-              <a:rPr b="1"/>
-              <a:t>الدمج</a:t>
-            </a:r>
-            <a:r>
-              <a:rPr/>
-              <a:t> يتفوّق على التيار وحده لكن ليس على الاهتزاز وحده.</a:t>
-            </a:r>
-          </a:p>
-          <a:p>
-            <a:pPr lvl="0"/>
-            <a:r>
-              <a:rPr b="1"/>
-              <a:t>اختيار المقياس مهم</a:t>
-            </a:r>
-            <a:r>
-              <a:rPr/>
-              <a:t>: الدقة المتوازنة كشفت انهيار صنف الأغلبية الذي تُخفيه الدقة الخام.</a:t>
-            </a:r>
-          </a:p>
-        </p:txBody>
-      </p:sp>
-    </p:spTree>
-  </p:cSld>
-</p:sld>
-</file>
-
-<file path=ppt/slides/slide21.xml><?xml version="1.0" encoding="utf-8"?>
-<p:sld xmlns:a="http://schemas.openxmlformats.org/drawingml/2006/main" xmlns:r="http://schemas.openxmlformats.org/officeDocument/2006/relationships" xmlns:p="http://schemas.openxmlformats.org/presentationml/2006/main">
-  <p:cSld>
-    <p:spTree>
-      <p:nvGrpSpPr>
-        <p:cNvPr id="1" name=""/>
-        <p:cNvGrpSpPr/>
-        <p:nvPr/>
-      </p:nvGrpSpPr>
-      <p:grpSpPr>
-        <a:xfrm>
-          <a:off x="0" y="0"/>
-          <a:ext cx="0" cy="0"/>
-          <a:chOff x="0" y="0"/>
-          <a:chExt cx="0" cy="0"/>
-        </a:xfrm>
-      </p:grpSpPr>
-      <p:sp>
-        <p:nvSpPr>
-          <p:cNvPr id="3" name="Content Placeholder 2"/>
-          <p:cNvSpPr>
-            <a:spLocks noGrp="1"/>
-          </p:cNvSpPr>
-          <p:nvPr>
-            <p:ph idx="1"/>
-          </p:nvPr>
-        </p:nvSpPr>
-        <p:spPr/>
-        <p:txBody>
-          <a:bodyPr/>
-          <a:lstStyle/>
-          <a:p>
-            <a:pPr lvl="0" indent="0" marL="0">
-              <a:spcBef>
-                <a:spcPts val="3000"/>
-              </a:spcBef>
-              <a:buNone/>
-            </a:pPr>
-            <a:r>
-              <a:rPr b="1"/>
-              <a:t>١٥. تجارب التحسين</a:t>
-            </a:r>
-          </a:p>
-          <a:p>
-            <a:pPr lvl="0"/>
-            <a:r>
-              <a:rPr b="1"/>
-              <a:t>الموازنة</a:t>
-            </a:r>
-            <a:r>
-              <a:rPr/>
-              <a:t> تمنع انهيار الأغلبية (استدعاء السليم للتيار 0.00 ⟵ 1.00).</a:t>
-            </a:r>
-          </a:p>
-          <a:p>
-            <a:pPr lvl="0"/>
-            <a:r>
-              <a:rPr b="1"/>
-              <a:t>حجم الصورة</a:t>
-            </a:r>
-            <a:r>
-              <a:rPr/>
-              <a:t>: يُحسّن التيار تدريجياً (0.68→0.76 من 96 إلى 224)؛ الاهتزاز مُشبَع.</a:t>
-            </a:r>
-          </a:p>
-          <a:p>
-            <a:pPr lvl="0"/>
-            <a:r>
-              <a:rPr b="1"/>
-              <a:t>منحنى التعلّم</a:t>
-            </a:r>
-            <a:r>
-              <a:rPr/>
-              <a:t>: الاهتزاز يكفيه ~46 صورة؛ التيار ثابت ~0.70 مهما زادت البيانات ⟵ القيد جودة الإشارة لا كميّتها.</a:t>
-            </a:r>
-          </a:p>
-        </p:txBody>
-      </p:sp>
-    </p:spTree>
-  </p:cSld>
-</p:sld>
-</file>
-
 <file path=ppt/slides/slide22.xml><?xml version="1.0" encoding="utf-8"?>
 <p:sld xmlns:a="http://schemas.openxmlformats.org/drawingml/2006/main" xmlns:r="http://schemas.openxmlformats.org/officeDocument/2006/relationships" xmlns:p="http://schemas.openxmlformats.org/presentationml/2006/main">
   <p:cSld>
@@ -4994,39 +4881,11 @@
           <a:lstStyle/>
           <a:p>
             <a:pPr lvl="0" indent="0" marL="0">
-              <a:spcBef>
-                <a:spcPts val="3000"/>
-              </a:spcBef>
               <a:buNone/>
             </a:pPr>
             <a:r>
-              <a:rPr b="1"/>
-              <a:t>١٦. القيود</a:t>
-            </a:r>
-          </a:p>
-          <a:p>
-            <a:pPr lvl="0"/>
-            <a:r>
-              <a:rPr b="1"/>
-              <a:t>4 تسجيلات سليمة فقط</a:t>
-            </a:r>
-            <a:r>
-              <a:rPr/>
-              <a:t> ⟵ النتيجة المثالية للاهتزاز لا تستبعد تماماً تعلّم “هوية التسجيل”.</a:t>
-            </a:r>
-          </a:p>
-          <a:p>
-            <a:pPr lvl="0"/>
-            <a:r>
-              <a:rPr/>
-              <a:t>إزالة المغنطة والحمل الزائد اصطناعية فقط.</a:t>
-            </a:r>
-          </a:p>
-          <a:p>
-            <a:pPr lvl="0"/>
-            <a:r>
-              <a:rPr/>
-              <a:t>مقارنة الدمج إرشادية لا مضبوطة بدقّة.</a:t>
+              <a:rPr/>
+              <a:t>تسجيلات محجوزة للاختبار، التمييز: سليم مقابل عطل بين اللفات.</a:t>
             </a:r>
           </a:p>
         </p:txBody>
@@ -5055,12 +4914,12 @@
       </p:grpSpPr>
       <p:sp>
         <p:nvSpPr>
-          <p:cNvPr id="3" name="Content Placeholder 2"/>
-          <p:cNvSpPr>
-            <a:spLocks noGrp="1"/>
-          </p:cNvSpPr>
-          <p:nvPr>
-            <p:ph idx="1"/>
+          <p:cNvPr id="4" name="Text Placeholder 3"/>
+          <p:cNvSpPr>
+            <a:spLocks noGrp="1"/>
+          </p:cNvSpPr>
+          <p:nvPr>
+            <p:ph idx="2" sz="half" type="body"/>
           </p:nvPr>
         </p:nvSpPr>
         <p:spPr/>
@@ -5076,33 +4935,41 @@
             </a:pPr>
             <a:r>
               <a:rPr b="1"/>
-              <a:t>١٧. الخلاصة والعمل المستقبلي</a:t>
-            </a:r>
-          </a:p>
-          <a:p>
-            <a:pPr lvl="0"/>
-            <a:r>
-              <a:rPr/>
-              <a:t>منظومة scalogram + CNN قابلة للتكرار تكشف الأعطال بين اللفات؛ </a:t>
-            </a:r>
-            <a:r>
-              <a:rPr b="1"/>
-              <a:t>الاهتزاز يبلغ دقة متوازنة 1.00</a:t>
-            </a:r>
-            <a:r>
-              <a:rPr/>
-              <a:t> على تسجيلات محجوزة.</a:t>
-            </a:r>
-          </a:p>
-          <a:p>
-            <a:pPr lvl="0"/>
-            <a:r>
-              <a:rPr/>
-              <a:t>مستقبلاً: تسجيلات مستقلّة أكثر؛ مجموعة دمج متعدّدة القنوات متزامنة؛ تصنيف حسب الشدّة؛ التفسيرية (Grad-CAM)؛ النشر اللحظي داخل المُشغّل.</a:t>
-            </a:r>
-          </a:p>
-        </p:txBody>
-      </p:sp>
+              <a:t>١٣. مصفوفات الالتباس</a:t>
+            </a:r>
+          </a:p>
+        </p:txBody>
+      </p:sp>
+      <p:pic>
+        <p:nvPicPr>
+          <p:cNvPr descr="../../results/confusion_real_2class.png" id="0" name="Picture 1"/>
+          <p:cNvPicPr>
+            <a:picLocks noGrp="1" noChangeAspect="1"/>
+          </p:cNvPicPr>
+          <p:nvPr/>
+        </p:nvPicPr>
+        <p:blipFill>
+          <a:blip r:embed="rId2"/>
+          <a:stretch>
+            <a:fillRect/>
+          </a:stretch>
+        </p:blipFill>
+        <p:spPr bwMode="auto">
+          <a:xfrm>
+            <a:off x="3568700" y="1130300"/>
+            <a:ext cx="5105400" cy="2540000"/>
+          </a:xfrm>
+          <a:prstGeom prst="rect">
+            <a:avLst/>
+          </a:prstGeom>
+          <a:noFill/>
+          <a:ln w="9525">
+            <a:noFill/>
+            <a:headEnd/>
+            <a:tailEnd/>
+          </a:ln>
+        </p:spPr>
+      </p:pic>
     </p:spTree>
   </p:cSld>
 </p:sld>
@@ -5127,6 +4994,366 @@
       </p:grpSpPr>
       <p:sp>
         <p:nvSpPr>
+          <p:cNvPr id="3" name="Content Placeholder 2"/>
+          <p:cNvSpPr>
+            <a:spLocks noGrp="1"/>
+          </p:cNvSpPr>
+          <p:nvPr>
+            <p:ph idx="1"/>
+          </p:nvPr>
+        </p:nvSpPr>
+        <p:spPr/>
+        <p:txBody>
+          <a:bodyPr/>
+          <a:lstStyle/>
+          <a:p>
+            <a:pPr lvl="0" indent="0" marL="0">
+              <a:buNone/>
+            </a:pPr>
+            <a:r>
+              <a:rPr/>
+              <a:t>الاهتزاز مثالي؛ التيار يُخطئ معظم الأعطال؛ الدمج بينهما.</a:t>
+            </a:r>
+          </a:p>
+        </p:txBody>
+      </p:sp>
+    </p:spTree>
+  </p:cSld>
+</p:sld>
+</file>
+
+<file path=ppt/slides/slide25.xml><?xml version="1.0" encoding="utf-8"?>
+<p:sld xmlns:a="http://schemas.openxmlformats.org/drawingml/2006/main" xmlns:r="http://schemas.openxmlformats.org/officeDocument/2006/relationships" xmlns:p="http://schemas.openxmlformats.org/presentationml/2006/main">
+  <p:cSld>
+    <p:spTree>
+      <p:nvGrpSpPr>
+        <p:cNvPr id="1" name=""/>
+        <p:cNvGrpSpPr/>
+        <p:nvPr/>
+      </p:nvGrpSpPr>
+      <p:grpSpPr>
+        <a:xfrm>
+          <a:off x="0" y="0"/>
+          <a:ext cx="0" cy="0"/>
+          <a:chOff x="0" y="0"/>
+          <a:chExt cx="0" cy="0"/>
+        </a:xfrm>
+      </p:grpSpPr>
+      <p:sp>
+        <p:nvSpPr>
+          <p:cNvPr id="3" name="Content Placeholder 2"/>
+          <p:cNvSpPr>
+            <a:spLocks noGrp="1"/>
+          </p:cNvSpPr>
+          <p:nvPr>
+            <p:ph idx="1"/>
+          </p:nvPr>
+        </p:nvSpPr>
+        <p:spPr/>
+        <p:txBody>
+          <a:bodyPr/>
+          <a:lstStyle/>
+          <a:p>
+            <a:pPr lvl="0" indent="0" marL="0">
+              <a:spcBef>
+                <a:spcPts val="3000"/>
+              </a:spcBef>
+              <a:buNone/>
+            </a:pPr>
+            <a:r>
+              <a:rPr b="1"/>
+              <a:t>١٤. التحليل</a:t>
+            </a:r>
+          </a:p>
+          <a:p>
+            <a:pPr lvl="0"/>
+            <a:r>
+              <a:rPr b="1"/>
+              <a:t>الاهتزاز ≫ التيار</a:t>
+            </a:r>
+            <a:r>
+              <a:rPr/>
+              <a:t> لكشف العطل بين اللفات — متوقّع فيزيائياً (الاهتزاز يستجيب مباشرة، وFOC يُخمد بصمة التيار).</a:t>
+            </a:r>
+          </a:p>
+          <a:p>
+            <a:pPr lvl="0"/>
+            <a:r>
+              <a:rPr b="1"/>
+              <a:t>الدمج</a:t>
+            </a:r>
+            <a:r>
+              <a:rPr/>
+              <a:t> يتفوّق على التيار وحده لكن ليس على الاهتزاز وحده.</a:t>
+            </a:r>
+          </a:p>
+          <a:p>
+            <a:pPr lvl="0"/>
+            <a:r>
+              <a:rPr b="1"/>
+              <a:t>اختيار المقياس مهم</a:t>
+            </a:r>
+            <a:r>
+              <a:rPr/>
+              <a:t>: الدقة المتوازنة كشفت انهيار صنف الأغلبية الذي تُخفيه الدقة الخام.</a:t>
+            </a:r>
+          </a:p>
+        </p:txBody>
+      </p:sp>
+    </p:spTree>
+  </p:cSld>
+</p:sld>
+</file>
+
+<file path=ppt/slides/slide26.xml><?xml version="1.0" encoding="utf-8"?>
+<p:sld xmlns:a="http://schemas.openxmlformats.org/drawingml/2006/main" xmlns:r="http://schemas.openxmlformats.org/officeDocument/2006/relationships" xmlns:p="http://schemas.openxmlformats.org/presentationml/2006/main">
+  <p:cSld>
+    <p:spTree>
+      <p:nvGrpSpPr>
+        <p:cNvPr id="1" name=""/>
+        <p:cNvGrpSpPr/>
+        <p:nvPr/>
+      </p:nvGrpSpPr>
+      <p:grpSpPr>
+        <a:xfrm>
+          <a:off x="0" y="0"/>
+          <a:ext cx="0" cy="0"/>
+          <a:chOff x="0" y="0"/>
+          <a:chExt cx="0" cy="0"/>
+        </a:xfrm>
+      </p:grpSpPr>
+      <p:sp>
+        <p:nvSpPr>
+          <p:cNvPr id="3" name="Content Placeholder 2"/>
+          <p:cNvSpPr>
+            <a:spLocks noGrp="1"/>
+          </p:cNvSpPr>
+          <p:nvPr>
+            <p:ph idx="1"/>
+          </p:nvPr>
+        </p:nvSpPr>
+        <p:spPr/>
+        <p:txBody>
+          <a:bodyPr/>
+          <a:lstStyle/>
+          <a:p>
+            <a:pPr lvl="0" indent="0" marL="0">
+              <a:spcBef>
+                <a:spcPts val="3000"/>
+              </a:spcBef>
+              <a:buNone/>
+            </a:pPr>
+            <a:r>
+              <a:rPr b="1"/>
+              <a:t>١٥. تجارب التحسين</a:t>
+            </a:r>
+          </a:p>
+          <a:p>
+            <a:pPr lvl="0"/>
+            <a:r>
+              <a:rPr b="1"/>
+              <a:t>الموازنة</a:t>
+            </a:r>
+            <a:r>
+              <a:rPr/>
+              <a:t> تمنع انهيار الأغلبية (استدعاء السليم للتيار 0.00 ⟵ 1.00).</a:t>
+            </a:r>
+          </a:p>
+          <a:p>
+            <a:pPr lvl="0"/>
+            <a:r>
+              <a:rPr b="1"/>
+              <a:t>حجم الصورة</a:t>
+            </a:r>
+            <a:r>
+              <a:rPr/>
+              <a:t>: يُحسّن التيار تدريجياً (0.68→0.76 من 96 إلى 224)؛ الاهتزاز مُشبَع.</a:t>
+            </a:r>
+          </a:p>
+          <a:p>
+            <a:pPr lvl="0"/>
+            <a:r>
+              <a:rPr b="1"/>
+              <a:t>منحنى التعلّم</a:t>
+            </a:r>
+            <a:r>
+              <a:rPr/>
+              <a:t>: الاهتزاز يكفيه ~46 صورة؛ التيار ثابت ~0.70 مهما زادت البيانات ⟵ القيد جودة الإشارة لا كميّتها.</a:t>
+            </a:r>
+          </a:p>
+        </p:txBody>
+      </p:sp>
+    </p:spTree>
+  </p:cSld>
+</p:sld>
+</file>
+
+<file path=ppt/slides/slide27.xml><?xml version="1.0" encoding="utf-8"?>
+<p:sld xmlns:a="http://schemas.openxmlformats.org/drawingml/2006/main" xmlns:r="http://schemas.openxmlformats.org/officeDocument/2006/relationships" xmlns:p="http://schemas.openxmlformats.org/presentationml/2006/main">
+  <p:cSld>
+    <p:spTree>
+      <p:nvGrpSpPr>
+        <p:cNvPr id="1" name=""/>
+        <p:cNvGrpSpPr/>
+        <p:nvPr/>
+      </p:nvGrpSpPr>
+      <p:grpSpPr>
+        <a:xfrm>
+          <a:off x="0" y="0"/>
+          <a:ext cx="0" cy="0"/>
+          <a:chOff x="0" y="0"/>
+          <a:chExt cx="0" cy="0"/>
+        </a:xfrm>
+      </p:grpSpPr>
+      <p:sp>
+        <p:nvSpPr>
+          <p:cNvPr id="3" name="Content Placeholder 2"/>
+          <p:cNvSpPr>
+            <a:spLocks noGrp="1"/>
+          </p:cNvSpPr>
+          <p:nvPr>
+            <p:ph idx="1"/>
+          </p:nvPr>
+        </p:nvSpPr>
+        <p:spPr/>
+        <p:txBody>
+          <a:bodyPr/>
+          <a:lstStyle/>
+          <a:p>
+            <a:pPr lvl="0" indent="0" marL="0">
+              <a:spcBef>
+                <a:spcPts val="3000"/>
+              </a:spcBef>
+              <a:buNone/>
+            </a:pPr>
+            <a:r>
+              <a:rPr b="1"/>
+              <a:t>١٦. القيود</a:t>
+            </a:r>
+          </a:p>
+          <a:p>
+            <a:pPr lvl="0"/>
+            <a:r>
+              <a:rPr b="1"/>
+              <a:t>4 تسجيلات سليمة فقط</a:t>
+            </a:r>
+            <a:r>
+              <a:rPr/>
+              <a:t> ⟵ النتيجة المثالية للاهتزاز لا تستبعد تماماً تعلّم “هوية التسجيل”.</a:t>
+            </a:r>
+          </a:p>
+          <a:p>
+            <a:pPr lvl="0"/>
+            <a:r>
+              <a:rPr/>
+              <a:t>إزالة المغنطة والحمل الزائد اصطناعية فقط.</a:t>
+            </a:r>
+          </a:p>
+          <a:p>
+            <a:pPr lvl="0"/>
+            <a:r>
+              <a:rPr/>
+              <a:t>مقارنة الدمج إرشادية لا مضبوطة بدقّة.</a:t>
+            </a:r>
+          </a:p>
+        </p:txBody>
+      </p:sp>
+    </p:spTree>
+  </p:cSld>
+</p:sld>
+</file>
+
+<file path=ppt/slides/slide28.xml><?xml version="1.0" encoding="utf-8"?>
+<p:sld xmlns:a="http://schemas.openxmlformats.org/drawingml/2006/main" xmlns:r="http://schemas.openxmlformats.org/officeDocument/2006/relationships" xmlns:p="http://schemas.openxmlformats.org/presentationml/2006/main">
+  <p:cSld>
+    <p:spTree>
+      <p:nvGrpSpPr>
+        <p:cNvPr id="1" name=""/>
+        <p:cNvGrpSpPr/>
+        <p:nvPr/>
+      </p:nvGrpSpPr>
+      <p:grpSpPr>
+        <a:xfrm>
+          <a:off x="0" y="0"/>
+          <a:ext cx="0" cy="0"/>
+          <a:chOff x="0" y="0"/>
+          <a:chExt cx="0" cy="0"/>
+        </a:xfrm>
+      </p:grpSpPr>
+      <p:sp>
+        <p:nvSpPr>
+          <p:cNvPr id="3" name="Content Placeholder 2"/>
+          <p:cNvSpPr>
+            <a:spLocks noGrp="1"/>
+          </p:cNvSpPr>
+          <p:nvPr>
+            <p:ph idx="1"/>
+          </p:nvPr>
+        </p:nvSpPr>
+        <p:spPr/>
+        <p:txBody>
+          <a:bodyPr/>
+          <a:lstStyle/>
+          <a:p>
+            <a:pPr lvl="0" indent="0" marL="0">
+              <a:spcBef>
+                <a:spcPts val="3000"/>
+              </a:spcBef>
+              <a:buNone/>
+            </a:pPr>
+            <a:r>
+              <a:rPr b="1"/>
+              <a:t>١٧. الخلاصة والعمل المستقبلي</a:t>
+            </a:r>
+          </a:p>
+          <a:p>
+            <a:pPr lvl="0"/>
+            <a:r>
+              <a:rPr/>
+              <a:t>منظومة scalogram + CNN قابلة للتكرار تكشف الأعطال بين اللفات؛ </a:t>
+            </a:r>
+            <a:r>
+              <a:rPr b="1"/>
+              <a:t>الاهتزاز يبلغ دقة متوازنة 1.00</a:t>
+            </a:r>
+            <a:r>
+              <a:rPr/>
+              <a:t> على تسجيلات محجوزة.</a:t>
+            </a:r>
+          </a:p>
+          <a:p>
+            <a:pPr lvl="0"/>
+            <a:r>
+              <a:rPr/>
+              <a:t>مستقبلاً: تسجيلات مستقلّة أكثر؛ مجموعة دمج متعدّدة القنوات متزامنة؛ تصنيف حسب الشدّة؛ التفسيرية (Grad-CAM)؛ النشر اللحظي داخل المُشغّل.</a:t>
+            </a:r>
+          </a:p>
+        </p:txBody>
+      </p:sp>
+    </p:spTree>
+  </p:cSld>
+</p:sld>
+</file>
+
+<file path=ppt/slides/slide29.xml><?xml version="1.0" encoding="utf-8"?>
+<p:sld xmlns:a="http://schemas.openxmlformats.org/drawingml/2006/main" xmlns:r="http://schemas.openxmlformats.org/officeDocument/2006/relationships" xmlns:p="http://schemas.openxmlformats.org/presentationml/2006/main">
+  <p:cSld>
+    <p:spTree>
+      <p:nvGrpSpPr>
+        <p:cNvPr id="1" name=""/>
+        <p:cNvGrpSpPr/>
+        <p:nvPr/>
+      </p:nvGrpSpPr>
+      <p:grpSpPr>
+        <a:xfrm>
+          <a:off x="0" y="0"/>
+          <a:ext cx="0" cy="0"/>
+          <a:chOff x="0" y="0"/>
+          <a:chExt cx="0" cy="0"/>
+        </a:xfrm>
+      </p:grpSpPr>
+      <p:sp>
+        <p:nvSpPr>
           <p:cNvPr id="2" name="Title 1"/>
           <p:cNvSpPr>
             <a:spLocks noGrp="1"/>
@@ -5687,7 +5914,7 @@
         </p:blipFill>
         <p:spPr bwMode="auto">
           <a:xfrm>
-            <a:off x="3568700" y="1320800"/>
+            <a:off x="3568700" y="1574800"/>
             <a:ext cx="5105400" cy="1638300"/>
           </a:xfrm>
           <a:prstGeom prst="rect">
@@ -5701,99 +5928,6 @@
           </a:ln>
         </p:spPr>
       </p:pic>
-      <p:sp>
-        <p:nvSpPr>
-          <p:cNvPr id="1" name="TextBox 3"/>
-          <p:cNvSpPr txBox="1"/>
-          <p:nvPr>
-            <p:ph idx="1"/>
-          </p:nvPr>
-        </p:nvSpPr>
-        <p:spPr>
-          <a:xfrm>
-            <a:off x="3568700" y="4076700"/>
-            <a:ext cx="5105400" cy="508000"/>
-          </a:xfrm>
-          <a:prstGeom prst="rect">
-            <a:avLst/>
-          </a:prstGeom>
-          <a:noFill/>
-        </p:spPr>
-        <p:txBody>
-          <a:bodyPr/>
-          <a:lstStyle/>
-          <a:p>
-            <a:pPr lvl="0" indent="0" marL="0" algn="ctr">
-              <a:buNone/>
-            </a:pPr>
-            <a:r>
-              <a:rPr/>
-              <a:t>w:780</a:t>
-            </a:r>
-          </a:p>
-        </p:txBody>
-      </p:sp>
-      <p:sp>
-        <p:nvSpPr>
-          <p:cNvPr id="3" name="Content Placeholder 2"/>
-          <p:cNvSpPr>
-            <a:spLocks noGrp="1"/>
-          </p:cNvSpPr>
-          <p:nvPr>
-            <p:ph idx="1"/>
-          </p:nvPr>
-        </p:nvSpPr>
-        <p:spPr/>
-        <p:txBody>
-          <a:bodyPr/>
-          <a:lstStyle/>
-          <a:p>
-            <a:pPr lvl="0"/>
-            <a:r>
-              <a:rPr/>
-              <a:t>عضو ثابت (ملف ثلاثي الطور) + عضو دوّار مغناطيسي؛ يُقاد بعاكس تحت </a:t>
-            </a:r>
-            <a:r>
-              <a:rPr b="1"/>
-              <a:t>FOC</a:t>
-            </a:r>
-            <a:r>
-              <a:rPr/>
-              <a:t>.</a:t>
-            </a:r>
-          </a:p>
-          <a:p>
-            <a:pPr lvl="0"/>
-            <a:r>
-              <a:rPr/>
-              <a:t>حلقة التيّار </a:t>
-            </a:r>
-            <a:r>
-              <a:rPr b="1"/>
-              <a:t>ترفض الاضطرابات ← تُخفي بصمة العطل في التيّار</a:t>
-            </a:r>
-            <a:r>
-              <a:rPr/>
-              <a:t>.</a:t>
-            </a:r>
-          </a:p>
-          <a:p>
-            <a:pPr lvl="0"/>
-            <a:r>
-              <a:rPr/>
-              <a:t>ولهذا </a:t>
-            </a:r>
-            <a:r>
-              <a:rPr b="1"/>
-              <a:t>يكشف الاهتزاز القِصَر بين اللفّات أفضل بكثير</a:t>
-            </a:r>
-            <a:r>
-              <a:rPr/>
-              <a:t> (نتيجتنا الأساسية).</a:t>
-            </a:r>
-          </a:p>
-        </p:txBody>
-      </p:sp>
     </p:spTree>
   </p:cSld>
 </p:sld>
@@ -5818,104 +5952,14 @@
       </p:grpSpPr>
       <p:sp>
         <p:nvSpPr>
-          <p:cNvPr id="4" name="Text Placeholder 3"/>
-          <p:cNvSpPr>
-            <a:spLocks noGrp="1"/>
-          </p:cNvSpPr>
-          <p:nvPr>
-            <p:ph idx="2" sz="half" type="body"/>
-          </p:nvPr>
-        </p:nvSpPr>
-        <p:spPr/>
-        <p:txBody>
-          <a:bodyPr/>
-          <a:lstStyle/>
-          <a:p>
-            <a:pPr lvl="0" indent="0" marL="0">
-              <a:spcBef>
-                <a:spcPts val="3000"/>
-              </a:spcBef>
-              <a:buNone/>
-            </a:pPr>
-            <a:r>
-              <a:rPr b="1"/>
-              <a:t>PMSM مقابل نظائره</a:t>
-            </a:r>
-          </a:p>
-        </p:txBody>
-      </p:sp>
-      <p:pic>
-        <p:nvPicPr>
-          <p:cNvPr descr="../figures/fig_motor_comparison.png" id="0" name="Picture 1"/>
-          <p:cNvPicPr>
-            <a:picLocks noGrp="1" noChangeAspect="1"/>
-          </p:cNvPicPr>
-          <p:nvPr/>
-        </p:nvPicPr>
-        <p:blipFill>
-          <a:blip r:embed="rId2"/>
-          <a:stretch>
-            <a:fillRect/>
-          </a:stretch>
-        </p:blipFill>
-        <p:spPr bwMode="auto">
-          <a:xfrm>
-            <a:off x="3568700" y="1270000"/>
-            <a:ext cx="5105400" cy="1727200"/>
-          </a:xfrm>
-          <a:prstGeom prst="rect">
-            <a:avLst/>
-          </a:prstGeom>
-          <a:noFill/>
-          <a:ln w="9525">
-            <a:noFill/>
-            <a:headEnd/>
-            <a:tailEnd/>
-          </a:ln>
-        </p:spPr>
-      </p:pic>
-      <p:sp>
-        <p:nvSpPr>
-          <p:cNvPr id="1" name="TextBox 3"/>
-          <p:cNvSpPr txBox="1"/>
+          <p:cNvPr id="3" name="Content Placeholder 2"/>
+          <p:cNvSpPr>
+            <a:spLocks noGrp="1"/>
+          </p:cNvSpPr>
           <p:nvPr>
             <p:ph idx="1"/>
           </p:nvPr>
         </p:nvSpPr>
-        <p:spPr>
-          <a:xfrm>
-            <a:off x="3568700" y="4076700"/>
-            <a:ext cx="5105400" cy="508000"/>
-          </a:xfrm>
-          <a:prstGeom prst="rect">
-            <a:avLst/>
-          </a:prstGeom>
-          <a:noFill/>
-        </p:spPr>
-        <p:txBody>
-          <a:bodyPr/>
-          <a:lstStyle/>
-          <a:p>
-            <a:pPr lvl="0" indent="0" marL="0" algn="ctr">
-              <a:buNone/>
-            </a:pPr>
-            <a:r>
-              <a:rPr/>
-              <a:t>w:880</a:t>
-            </a:r>
-          </a:p>
-        </p:txBody>
-      </p:sp>
-      <p:sp>
-        <p:nvSpPr>
-          <p:cNvPr id="3" name="Content Placeholder 2"/>
-          <p:cNvSpPr>
-            <a:spLocks noGrp="1"/>
-          </p:cNvSpPr>
-          <p:nvPr>
-            <p:ph idx="1"/>
-          </p:nvPr>
-        </p:nvSpPr>
         <p:spPr/>
         <p:txBody>
           <a:bodyPr/>
@@ -5924,45 +5968,45 @@
             <a:pPr lvl="0"/>
             <a:r>
               <a:rPr/>
-              <a:t>مقابل </a:t>
-            </a:r>
-            <a:r>
-              <a:rPr b="1"/>
-              <a:t>PMDC</a:t>
-            </a:r>
-            <a:r>
-              <a:rPr/>
-              <a:t>: نفس سهولة التحكّم بالعزم، لكن دون فُرَش ← صيانة أقل.</a:t>
+              <a:t>عضو ثابت (ملف ثلاثي الطور) + عضو دوّار مغناطيسي؛ يُقاد بعاكس تحت </a:t>
+            </a:r>
+            <a:r>
+              <a:rPr b="1"/>
+              <a:t>FOC</a:t>
+            </a:r>
+            <a:r>
+              <a:rPr/>
+              <a:t>.</a:t>
             </a:r>
           </a:p>
           <a:p>
             <a:pPr lvl="0"/>
             <a:r>
               <a:rPr/>
-              <a:t>مقابل </a:t>
-            </a:r>
-            <a:r>
-              <a:rPr b="1"/>
-              <a:t>BLDC</a:t>
-            </a:r>
-            <a:r>
-              <a:rPr/>
-              <a:t>: قوة دافعة جيبية + FOC ← عزم أنعم وكفاءة أعلى.</a:t>
+              <a:t>حلقة التيّار </a:t>
+            </a:r>
+            <a:r>
+              <a:rPr b="1"/>
+              <a:t>ترفض الاضطرابات ← تُخفي بصمة العطل في التيّار</a:t>
+            </a:r>
+            <a:r>
+              <a:rPr/>
+              <a:t>.</a:t>
             </a:r>
           </a:p>
           <a:p>
             <a:pPr lvl="0"/>
             <a:r>
               <a:rPr/>
-              <a:t>مقابل </a:t>
-            </a:r>
-            <a:r>
-              <a:rPr b="1"/>
-              <a:t>الحثّي</a:t>
-            </a:r>
-            <a:r>
-              <a:rPr/>
-              <a:t>: لا تيّار/انزلاق في العضو الدوّار ← كفاءة وكثافة عزم أعلى.</a:t>
+              <a:t>ولهذا </a:t>
+            </a:r>
+            <a:r>
+              <a:rPr b="1"/>
+              <a:t>يكشف الاهتزاز القِصَر بين اللفّات أفضل بكثير</a:t>
+            </a:r>
+            <a:r>
+              <a:rPr/>
+              <a:t> (نتيجتنا الأساسية).</a:t>
             </a:r>
           </a:p>
         </p:txBody>
@@ -6012,14 +6056,14 @@
             </a:pPr>
             <a:r>
               <a:rPr b="1"/>
-              <a:t>كشف العطل — اليوم مقابل هذا العمل</a:t>
+              <a:t>PMSM مقابل نظائره</a:t>
             </a:r>
           </a:p>
         </p:txBody>
       </p:sp>
       <p:pic>
         <p:nvPicPr>
-          <p:cNvPr descr="../figures/fig_detection_taxonomy.png" id="0" name="Picture 1"/>
+          <p:cNvPr descr="../figures/fig_motor_comparison.png" id="0" name="Picture 1"/>
           <p:cNvPicPr>
             <a:picLocks noGrp="1" noChangeAspect="1"/>
           </p:cNvPicPr>
@@ -6033,8 +6077,8 @@
         </p:blipFill>
         <p:spPr bwMode="auto">
           <a:xfrm>
-            <a:off x="3568700" y="1130300"/>
-            <a:ext cx="5105400" cy="2006600"/>
+            <a:off x="3568700" y="1524000"/>
+            <a:ext cx="5105400" cy="1727200"/>
           </a:xfrm>
           <a:prstGeom prst="rect">
             <a:avLst/>
@@ -6047,95 +6091,6 @@
           </a:ln>
         </p:spPr>
       </p:pic>
-      <p:sp>
-        <p:nvSpPr>
-          <p:cNvPr id="1" name="TextBox 3"/>
-          <p:cNvSpPr txBox="1"/>
-          <p:nvPr>
-            <p:ph idx="1"/>
-          </p:nvPr>
-        </p:nvSpPr>
-        <p:spPr>
-          <a:xfrm>
-            <a:off x="3568700" y="4076700"/>
-            <a:ext cx="5105400" cy="508000"/>
-          </a:xfrm>
-          <a:prstGeom prst="rect">
-            <a:avLst/>
-          </a:prstGeom>
-          <a:noFill/>
-        </p:spPr>
-        <p:txBody>
-          <a:bodyPr/>
-          <a:lstStyle/>
-          <a:p>
-            <a:pPr lvl="0" indent="0" marL="0" algn="ctr">
-              <a:buNone/>
-            </a:pPr>
-            <a:r>
-              <a:rPr/>
-              <a:t>w:820</a:t>
-            </a:r>
-          </a:p>
-        </p:txBody>
-      </p:sp>
-      <p:sp>
-        <p:nvSpPr>
-          <p:cNvPr id="3" name="Content Placeholder 2"/>
-          <p:cNvSpPr>
-            <a:spLocks noGrp="1"/>
-          </p:cNvSpPr>
-          <p:nvPr>
-            <p:ph idx="1"/>
-          </p:nvPr>
-        </p:nvSpPr>
-        <p:spPr/>
-        <p:txBody>
-          <a:bodyPr/>
-          <a:lstStyle/>
-          <a:p>
-            <a:pPr lvl="0"/>
-            <a:r>
-              <a:rPr/>
-              <a:t>يدوي/خارج الخط (حراري، </a:t>
-            </a:r>
-            <a:r>
-              <a:rPr b="1"/>
-              <a:t>Megger</a:t>
-            </a:r>
-            <a:r>
-              <a:rPr/>
-              <a:t>، موجة صاعقة) ← يتطلّب إيقافاً، دوري.</a:t>
-            </a:r>
-          </a:p>
-          <a:p>
-            <a:pPr lvl="0"/>
-            <a:r>
-              <a:rPr/>
-              <a:t>متّصل MCSA/اهتزاز FFT ← عتبات ثابتة، يخدعها الحِمل/السرعة.</a:t>
-            </a:r>
-          </a:p>
-          <a:p>
-            <a:pPr lvl="0"/>
-            <a:r>
-              <a:rPr b="1"/>
-              <a:t>مخطط CWT + CNN</a:t>
-            </a:r>
-            <a:r>
-              <a:rPr/>
-              <a:t> ← يتعلّم الخصائص، متين، يكشف </a:t>
-            </a:r>
-            <a:r>
-              <a:rPr b="1"/>
-              <a:t>أبكر</a:t>
-            </a:r>
-            <a:r>
-              <a:rPr/>
-              <a:t>.</a:t>
-            </a:r>
-          </a:p>
-        </p:txBody>
-      </p:sp>
     </p:spTree>
   </p:cSld>
 </p:sld>

</xml_diff>

<commit_message>
Fill cover (Aleppo Univ. / Mechatronics / Eng. Saad Almoustafa); add Grad-CAM + interactive figures
- Cover/affiliation filled across EN+AR report, slides, engineering chapter, and the
  dashboard sidebar: Aleppo University — Faculty of Electrical & Electronic
  Engineering, Department of Mechatronics Engineering; Supervisor Eng. Saad
  Almoustafa; Fourth Year. Students: Mulham Fetna, Mohammad Zein Qabbani.
- Dashboard: Grad-CAM panel in the Test Lab (overlays where the CNN looks on the
  scalogram; Keras-3-safe layer-walk implementation) + interactive Plotly figures
  (back-EMF, torque-speed, MCSA spectrum, detection-vs-severity) in the Motor &
  Control and Fault Detection sections.
- Rebuilt all EN+AR PDFs/PPTX/DOCX with the real cover.

Co-Authored-By: Claude Opus 4.8 (1M context) <noreply@anthropic.com>
</commit_message>
<xml_diff>
--- a/docs/build/slides-ar.pptx
+++ b/docs/build/slides-ar.pptx
@@ -4309,7 +4309,7 @@
             </a:pPr>
             <a:r>
               <a:rPr b="1"/>
-              <a:t>«اسم الجامعة — الكلية»</a:t>
+              <a:t>جامعة حلب — كلية الهندسة الكهربائية والإلكترونية</a:t>
             </a:r>
             <a:r>
               <a:rPr/>
@@ -4317,7 +4317,7 @@
             </a:r>
             <a:r>
               <a:rPr b="1"/>
-              <a:t>«القسم / الاختصاص»</a:t>
+              <a:t>قسم هندسة الميكاترونيكس</a:t>
             </a:r>
           </a:p>
           <a:p>
@@ -4351,15 +4351,15 @@
             </a:r>
             <a:r>
               <a:rPr b="1"/>
-              <a:t>«د. اسم المشرف»</a:t>
-            </a:r>
-            <a:r>
-              <a:rPr/>
-              <a:t> · العام الدراسي: </a:t>
-            </a:r>
-            <a:r>
-              <a:rPr b="1"/>
-              <a:t>«2025–2026»</a:t>
+              <a:t>م. سعد المصطفى</a:t>
+            </a:r>
+            <a:r>
+              <a:rPr/>
+              <a:t> · السنة: </a:t>
+            </a:r>
+            <a:r>
+              <a:rPr b="1"/>
+              <a:t>السنة الرابعة</a:t>
             </a:r>
           </a:p>
         </p:txBody>

</xml_diff>